<commit_message>
M7: fix SOP supporting-file mismatch, add SWOT-to-slide-deck section (HTML+PDF+PPT); CONTEXT.md checkpoint 26
</commit_message>
<xml_diff>
--- a/K2-Produktivitas/M07-Dokumen-Riset/K2-M07-Dokumen-Riset.pptx
+++ b/K2-Produktivitas/M07-Dokumen-Riset/K2-M07-Dokumen-Riset.pptx
@@ -12,9 +12,10 @@
     <p:sldId id="260" r:id="rId6"/>
     <p:sldId id="261" r:id="rId7"/>
     <p:sldId id="262" r:id="rId8"/>
+    <p:sldId id="263" r:id="rId9"/>
   </p:sldIdLst>
   <p:notesMasterIdLst>
-    <p:notesMasterId r:id="rId9"/>
+    <p:notesMasterId r:id="rId10"/>
   </p:notesMasterIdLst>
   <p:sldSz cx="12191695" cy="6858000"/>
   <p:notesSz cx="6858000" cy="12191695"/>
@@ -1060,6 +1061,94 @@
             <a:fld id="{F7021451-1387-4CA6-816F-3879F97B5CBC}" type="slidenum">
               <a:rPr lang="en-US"/>
               <a:t>7</a:t>
+            </a:fld>
+            <a:endParaRPr lang="en-US"/>
+          </a:p>
+        </p:txBody>
+      </p:sp>
+    </p:spTree>
+    <p:extLst>
+      <p:ext uri="{BB962C8B-B14F-4D97-AF65-F5344CB8AC3E}">
+        <p14:creationId xmlns:p14="http://schemas.microsoft.com/office/powerpoint/2010/main" val="1024086991"/>
+      </p:ext>
+    </p:extLst>
+  </p:cSld>
+  <p:clrMapOvr>
+    <a:masterClrMapping/>
+  </p:clrMapOvr>
+</p:notes>
+</file>
+
+<file path=ppt/notesSlides/notesSlide8.xml><?xml version="1.0" encoding="utf-8"?>
+<p:notes xmlns:a="http://schemas.openxmlformats.org/drawingml/2006/main" xmlns:r="http://schemas.openxmlformats.org/officeDocument/2006/relationships" xmlns:p="http://schemas.openxmlformats.org/presentationml/2006/main">
+  <p:cSld>
+    <p:spTree>
+      <p:nvGrpSpPr>
+        <p:cNvPr id="1" name=""/>
+        <p:cNvGrpSpPr/>
+        <p:nvPr/>
+      </p:nvGrpSpPr>
+      <p:grpSpPr>
+        <a:xfrm>
+          <a:off x="0" y="0"/>
+          <a:ext cx="0" cy="0"/>
+          <a:chOff x="0" y="0"/>
+          <a:chExt cx="0" cy="0"/>
+        </a:xfrm>
+      </p:grpSpPr>
+      <p:sp>
+        <p:nvSpPr>
+          <p:cNvPr id="2" name="Slide Image Placeholder 1"/>
+          <p:cNvSpPr>
+            <a:spLocks noGrp="1" noRot="1" noChangeAspect="1"/>
+          </p:cNvSpPr>
+          <p:nvPr>
+            <p:ph type="sldImg"/>
+          </p:nvPr>
+        </p:nvSpPr>
+        <p:spPr/>
+      </p:sp>
+      <p:sp>
+        <p:nvSpPr>
+          <p:cNvPr id="3" name="Notes Placeholder 2"/>
+          <p:cNvSpPr>
+            <a:spLocks noGrp="1"/>
+          </p:cNvSpPr>
+          <p:nvPr>
+            <p:ph type="body" idx="1"/>
+          </p:nvPr>
+        </p:nvSpPr>
+        <p:spPr/>
+        <p:txBody>
+          <a:bodyPr/>
+          <a:lstStyle/>
+          <a:p>
+            <a:r>
+              <a:rPr lang="en-US" dirty="0"/>
+              <a:t/>
+            </a:r>
+            <a:endParaRPr lang="en-US" dirty="0"/>
+          </a:p>
+        </p:txBody>
+      </p:sp>
+      <p:sp>
+        <p:nvSpPr>
+          <p:cNvPr id="4" name="Slide Number Placeholder 3"/>
+          <p:cNvSpPr>
+            <a:spLocks noGrp="1"/>
+          </p:cNvSpPr>
+          <p:nvPr>
+            <p:ph type="sldNum" sz="quarter" idx="10"/>
+          </p:nvPr>
+        </p:nvSpPr>
+        <p:spPr/>
+        <p:txBody>
+          <a:bodyPr/>
+          <a:lstStyle/>
+          <a:p>
+            <a:fld id="{F7021451-1387-4CA6-816F-3879F97B5CBC}" type="slidenum">
+              <a:rPr lang="en-US"/>
+              <a:t>8</a:t>
             </a:fld>
             <a:endParaRPr lang="en-US"/>
           </a:p>
@@ -4840,7 +4929,7 @@
                 <a:ea typeface="Helvetica" pitchFamily="34" charset="-122"/>
                 <a:cs typeface="Helvetica" pitchFamily="34" charset="-120"/>
               </a:rPr>
-              <a:t>Latihan &amp; Output</a:t>
+              <a:t>SWOT → Slide Presentasi</a:t>
             </a:r>
             <a:endParaRPr lang="en-US" sz="2200" dirty="0"/>
           </a:p>
@@ -4879,7 +4968,7 @@
                 <a:ea typeface="Helvetica" pitchFamily="34" charset="-122"/>
                 <a:cs typeface="Helvetica" pitchFamily="34" charset="-120"/>
               </a:rPr>
-              <a:t>PRAKTIKKAN KEEMPAT SKILL DI KERJAANMU SENDIRI</a:t>
+              <a:t>KAPAN DIPAKAI</a:t>
             </a:r>
             <a:endParaRPr lang="en-US" sz="1250" dirty="0"/>
           </a:p>
@@ -4887,26 +4976,68 @@
       </p:sp>
       <p:sp>
         <p:nvSpPr>
-          <p:cNvPr id="8" name="Shape 6"/>
+          <p:cNvPr id="8" name="Text 6"/>
           <p:cNvSpPr/>
           <p:nvPr/>
         </p:nvSpPr>
         <p:spPr>
           <a:xfrm>
             <a:off x="548640" y="2112264"/>
-            <a:ext cx="11094415" cy="1236853"/>
+            <a:ext cx="11094415" cy="498734"/>
+          </a:xfrm>
+          <a:prstGeom prst="rect">
+            <a:avLst/>
+          </a:prstGeom>
+          <a:noFill/>
+          <a:ln/>
+        </p:spPr>
+        <p:txBody>
+          <a:bodyPr wrap="square" lIns="0" tIns="0" rIns="0" bIns="0" rtlCol="0" anchor="t"/>
+          <a:lstStyle/>
+          <a:p>
+            <a:pPr indent="0" marL="0">
+              <a:lnSpc>
+                <a:spcPct val="128000"/>
+              </a:lnSpc>
+              <a:buNone/>
+            </a:pPr>
+            <a:r>
+              <a:rPr lang="en-US" sz="1300" dirty="0">
+                <a:solidFill>
+                  <a:srgbClr val="23283A"/>
+                </a:solidFill>
+                <a:latin typeface="Helvetica" pitchFamily="34" charset="0"/>
+                <a:ea typeface="Helvetica" pitchFamily="34" charset="-122"/>
+                <a:cs typeface="Helvetica" pitchFamily="34" charset="-120"/>
+              </a:rPr>
+              <a:t>SWOT atau riset yang sudah kamu buat biasanya perlu dipresentasikan — ke partner bisnis, calon investor, atau tim internal. Daripada mengetik ulang manual di PowerPoint, minta Claude langsung susun jadi slide.</a:t>
+            </a:r>
+            <a:endParaRPr lang="en-US" sz="1300" dirty="0"/>
+          </a:p>
+        </p:txBody>
+      </p:sp>
+      <p:sp>
+        <p:nvSpPr>
+          <p:cNvPr id="9" name="Shape 7"/>
+          <p:cNvSpPr/>
+          <p:nvPr/>
+        </p:nvSpPr>
+        <p:spPr>
+          <a:xfrm>
+            <a:off x="548640" y="2848742"/>
+            <a:ext cx="11094415" cy="1429283"/>
           </a:xfrm>
           <a:prstGeom prst="roundRect">
             <a:avLst>
-              <a:gd name="adj" fmla="val 7393"/>
+              <a:gd name="adj" fmla="val 6398"/>
             </a:avLst>
           </a:prstGeom>
           <a:solidFill>
-            <a:srgbClr val="EAFAF0"/>
+            <a:srgbClr val="141D33"/>
           </a:solidFill>
           <a:ln w="12700">
             <a:solidFill>
-              <a:srgbClr val="B8E6C9"/>
+              <a:srgbClr val="6849F6"/>
             </a:solidFill>
             <a:prstDash val="solid"/>
           </a:ln>
@@ -4914,14 +5045,14 @@
       </p:sp>
       <p:sp>
         <p:nvSpPr>
-          <p:cNvPr id="9" name="Text 7"/>
-          <p:cNvSpPr/>
-          <p:nvPr/>
-        </p:nvSpPr>
-        <p:spPr>
-          <a:xfrm>
-            <a:off x="749808" y="2313432"/>
-            <a:ext cx="10692079" cy="274320"/>
+          <p:cNvPr id="10" name="Text 8"/>
+          <p:cNvSpPr/>
+          <p:nvPr/>
+        </p:nvSpPr>
+        <p:spPr>
+          <a:xfrm>
+            <a:off x="768096" y="3068198"/>
+            <a:ext cx="10655503" cy="256032"/>
           </a:xfrm>
           <a:prstGeom prst="rect">
             <a:avLst/>
@@ -4937,30 +5068,30 @@
               <a:buNone/>
             </a:pPr>
             <a:r>
-              <a:rPr lang="en-US" sz="1250" b="1" spc="30" kern="0" dirty="0">
-                <a:solidFill>
-                  <a:srgbClr val="1A7A44"/>
-                </a:solidFill>
-                <a:latin typeface="Helvetica" pitchFamily="34" charset="0"/>
-                <a:ea typeface="Helvetica" pitchFamily="34" charset="-122"/>
-                <a:cs typeface="Helvetica" pitchFamily="34" charset="-120"/>
-              </a:rPr>
-              <a:t>■  LATIHAN</a:t>
-            </a:r>
-            <a:endParaRPr lang="en-US" sz="1250" dirty="0"/>
-          </a:p>
-        </p:txBody>
-      </p:sp>
-      <p:sp>
-        <p:nvSpPr>
-          <p:cNvPr id="10" name="Text 8"/>
-          <p:cNvSpPr/>
-          <p:nvPr/>
-        </p:nvSpPr>
-        <p:spPr>
-          <a:xfrm>
-            <a:off x="749808" y="2660904"/>
-            <a:ext cx="10692079" cy="487045"/>
+              <a:rPr lang="en-US" sz="1150" b="1" spc="30" kern="0" dirty="0">
+                <a:solidFill>
+                  <a:srgbClr val="8B7CF6"/>
+                </a:solidFill>
+                <a:latin typeface="Helvetica" pitchFamily="34" charset="0"/>
+                <a:ea typeface="Helvetica" pitchFamily="34" charset="-122"/>
+                <a:cs typeface="Helvetica" pitchFamily="34" charset="-120"/>
+              </a:rPr>
+              <a:t>PROMPT</a:t>
+            </a:r>
+            <a:endParaRPr lang="en-US" sz="1150" dirty="0"/>
+          </a:p>
+        </p:txBody>
+      </p:sp>
+      <p:sp>
+        <p:nvSpPr>
+          <p:cNvPr id="11" name="Text 9"/>
+          <p:cNvSpPr/>
+          <p:nvPr/>
+        </p:nvSpPr>
+        <p:spPr>
+          <a:xfrm>
+            <a:off x="768096" y="3415670"/>
+            <a:ext cx="10655503" cy="642899"/>
           </a:xfrm>
           <a:prstGeom prst="rect">
             <a:avLst/>
@@ -4979,123 +5110,57 @@
               <a:buNone/>
             </a:pPr>
             <a:r>
+              <a:rPr lang="en-US" sz="1100" dirty="0">
+                <a:solidFill>
+                  <a:srgbClr val="C7CDE0"/>
+                </a:solidFill>
+                <a:latin typeface="Helvetica" pitchFamily="34" charset="0"/>
+                <a:ea typeface="Helvetica" pitchFamily="34" charset="-122"/>
+                <a:cs typeface="Helvetica" pitchFamily="34" charset="-120"/>
+              </a:rPr>
+              <a:t>Dari SWOT tas kanvas yang sudah kita buat tadi, buatkan sebagai file presentasi (.pptx): 1 slide judul, lalu 1 slide per kuadran dengan judul singkat dan 3-4 bullet point per slide, dan 1 slide kesimpulan dengan rekomendasi. Desain simpel dan rapi, siap dipakai presentasi atau dipoles lebih lanjut di PowerPoint atau Google Slides.</a:t>
+            </a:r>
+            <a:endParaRPr lang="en-US" sz="1100" dirty="0"/>
+          </a:p>
+        </p:txBody>
+      </p:sp>
+      <p:sp>
+        <p:nvSpPr>
+          <p:cNvPr id="12" name="Text 10"/>
+          <p:cNvSpPr/>
+          <p:nvPr/>
+        </p:nvSpPr>
+        <p:spPr>
+          <a:xfrm>
+            <a:off x="548640" y="4515769"/>
+            <a:ext cx="11094415" cy="479552"/>
+          </a:xfrm>
+          <a:prstGeom prst="rect">
+            <a:avLst/>
+          </a:prstGeom>
+          <a:noFill/>
+          <a:ln/>
+        </p:spPr>
+        <p:txBody>
+          <a:bodyPr wrap="square" lIns="0" tIns="0" rIns="0" bIns="0" rtlCol="0" anchor="t"/>
+          <a:lstStyle/>
+          <a:p>
+            <a:pPr indent="0" marL="0">
+              <a:lnSpc>
+                <a:spcPct val="128000"/>
+              </a:lnSpc>
+              <a:buNone/>
+            </a:pPr>
+            <a:r>
               <a:rPr lang="en-US" sz="1250" dirty="0">
                 <a:solidFill>
-                  <a:srgbClr val="23283A"/>
-                </a:solidFill>
-                <a:latin typeface="Helvetica" pitchFamily="34" charset="0"/>
-                <a:ea typeface="Helvetica" pitchFamily="34" charset="-122"/>
-                <a:cs typeface="Helvetica" pitchFamily="34" charset="-120"/>
-              </a:rPr>
-              <a:t>Ambil 1 catatan rapat terakhir → minta action items. Pilih 1 dokumen yang "menunggu" dibaca → minta ringkasan sesuai keputusan yang perlu kamu buat. Jelaskan 1 keputusan bisnis yang dipertimbangkan → minta SWOT. Ceritakan 1 proses kerja → minta SOP.</a:t>
-            </a:r>
-            <a:endParaRPr lang="en-US" sz="1250" dirty="0"/>
-          </a:p>
-        </p:txBody>
-      </p:sp>
-      <p:sp>
-        <p:nvSpPr>
-          <p:cNvPr id="11" name="Shape 9"/>
-          <p:cNvSpPr/>
-          <p:nvPr/>
-        </p:nvSpPr>
-        <p:spPr>
-          <a:xfrm>
-            <a:off x="548640" y="3586861"/>
-            <a:ext cx="11094415" cy="993331"/>
-          </a:xfrm>
-          <a:prstGeom prst="roundRect">
-            <a:avLst>
-              <a:gd name="adj" fmla="val 9205"/>
-            </a:avLst>
-          </a:prstGeom>
-          <a:solidFill>
-            <a:srgbClr val="EAFAF0"/>
-          </a:solidFill>
-          <a:ln w="12700">
-            <a:solidFill>
-              <a:srgbClr val="B8E6C9"/>
-            </a:solidFill>
-            <a:prstDash val="solid"/>
-          </a:ln>
-        </p:spPr>
-      </p:sp>
-      <p:sp>
-        <p:nvSpPr>
-          <p:cNvPr id="12" name="Text 10"/>
-          <p:cNvSpPr/>
-          <p:nvPr/>
-        </p:nvSpPr>
-        <p:spPr>
-          <a:xfrm>
-            <a:off x="749808" y="3788029"/>
-            <a:ext cx="10692079" cy="274320"/>
-          </a:xfrm>
-          <a:prstGeom prst="rect">
-            <a:avLst/>
-          </a:prstGeom>
-          <a:noFill/>
-          <a:ln/>
-        </p:spPr>
-        <p:txBody>
-          <a:bodyPr wrap="square" lIns="0" tIns="0" rIns="0" bIns="0" rtlCol="0" anchor="ctr"/>
-          <a:lstStyle/>
-          <a:p>
-            <a:pPr indent="0" marL="0">
-              <a:buNone/>
-            </a:pPr>
-            <a:r>
-              <a:rPr lang="en-US" sz="1250" b="1" spc="30" kern="0" dirty="0">
-                <a:solidFill>
-                  <a:srgbClr val="1A7A44"/>
-                </a:solidFill>
-                <a:latin typeface="Helvetica" pitchFamily="34" charset="0"/>
-                <a:ea typeface="Helvetica" pitchFamily="34" charset="-122"/>
-                <a:cs typeface="Helvetica" pitchFamily="34" charset="-120"/>
-              </a:rPr>
-              <a:t>■  OUTPUT</a:t>
-            </a:r>
-            <a:endParaRPr lang="en-US" sz="1250" dirty="0"/>
-          </a:p>
-        </p:txBody>
-      </p:sp>
-      <p:sp>
-        <p:nvSpPr>
-          <p:cNvPr id="13" name="Text 11"/>
-          <p:cNvSpPr/>
-          <p:nvPr/>
-        </p:nvSpPr>
-        <p:spPr>
-          <a:xfrm>
-            <a:off x="749808" y="4135501"/>
-            <a:ext cx="10692079" cy="243523"/>
-          </a:xfrm>
-          <a:prstGeom prst="rect">
-            <a:avLst/>
-          </a:prstGeom>
-          <a:noFill/>
-          <a:ln/>
-        </p:spPr>
-        <p:txBody>
-          <a:bodyPr wrap="square" lIns="0" tIns="0" rIns="0" bIns="0" rtlCol="0" anchor="t"/>
-          <a:lstStyle/>
-          <a:p>
-            <a:pPr indent="0" marL="0">
-              <a:lnSpc>
-                <a:spcPct val="130000"/>
-              </a:lnSpc>
-              <a:buNone/>
-            </a:pPr>
-            <a:r>
-              <a:rPr lang="en-US" sz="1250" dirty="0">
-                <a:solidFill>
-                  <a:srgbClr val="23283A"/>
-                </a:solidFill>
-                <a:latin typeface="Helvetica" pitchFamily="34" charset="0"/>
-                <a:ea typeface="Helvetica" pitchFamily="34" charset="-122"/>
-                <a:cs typeface="Helvetica" pitchFamily="34" charset="-120"/>
-              </a:rPr>
-              <a:t>4 output siap pakai: tabel action items, ringkasan dokumen, SWOT 1 halaman, dan 1 SOP untuk pegawai baru.</a:t>
+                  <a:srgbClr val="6B7280"/>
+                </a:solidFill>
+                <a:latin typeface="Helvetica" pitchFamily="34" charset="0"/>
+                <a:ea typeface="Helvetica" pitchFamily="34" charset="-122"/>
+                <a:cs typeface="Helvetica" pitchFamily="34" charset="-120"/>
+              </a:rPr>
+              <a:t>Belum bisa bikin file langsung? Prompt yang sama tetap menghasilkan teks terstruktur per slide — tinggal copy-paste manual ke PowerPoint atau Google Slides.</a:t>
             </a:r>
             <a:endParaRPr lang="en-US" sz="1250" dirty="0"/>
           </a:p>
@@ -5112,6 +5177,464 @@
 <file path=ppt/slides/slide7.xml><?xml version="1.0" encoding="utf-8"?>
 <p:sld xmlns:a="http://schemas.openxmlformats.org/drawingml/2006/main" xmlns:r="http://schemas.openxmlformats.org/officeDocument/2006/relationships" xmlns:p="http://schemas.openxmlformats.org/presentationml/2006/main">
   <p:cSld name="Slide 7">
+    <p:bg>
+      <p:bgPr>
+        <a:solidFill>
+          <a:srgbClr val="FFFFFF"/>
+        </a:solidFill>
+      </p:bgPr>
+    </p:bg>
+    <p:spTree>
+      <p:nvGrpSpPr>
+        <p:cNvPr id="1" name=""/>
+        <p:cNvGrpSpPr/>
+        <p:nvPr/>
+      </p:nvGrpSpPr>
+      <p:grpSpPr>
+        <a:xfrm>
+          <a:off x="0" y="0"/>
+          <a:ext cx="0" cy="0"/>
+          <a:chOff x="0" y="0"/>
+          <a:chExt cx="0" cy="0"/>
+        </a:xfrm>
+      </p:grpSpPr>
+      <p:sp>
+        <p:nvSpPr>
+          <p:cNvPr id="2" name="Shape 0"/>
+          <p:cNvSpPr/>
+          <p:nvPr/>
+        </p:nvSpPr>
+        <p:spPr>
+          <a:xfrm>
+            <a:off x="0" y="0"/>
+            <a:ext cx="12191695" cy="960120"/>
+          </a:xfrm>
+          <a:prstGeom prst="rect">
+            <a:avLst/>
+          </a:prstGeom>
+          <a:solidFill>
+            <a:srgbClr val="0D1321"/>
+          </a:solidFill>
+          <a:ln/>
+        </p:spPr>
+      </p:sp>
+      <p:sp>
+        <p:nvSpPr>
+          <p:cNvPr id="3" name="Shape 1"/>
+          <p:cNvSpPr/>
+          <p:nvPr/>
+        </p:nvSpPr>
+        <p:spPr>
+          <a:xfrm>
+            <a:off x="0" y="960120"/>
+            <a:ext cx="12191695" cy="41148"/>
+          </a:xfrm>
+          <a:prstGeom prst="rect">
+            <a:avLst/>
+          </a:prstGeom>
+          <a:solidFill>
+            <a:srgbClr val="6849F6"/>
+          </a:solidFill>
+          <a:ln/>
+        </p:spPr>
+      </p:sp>
+      <p:sp>
+        <p:nvSpPr>
+          <p:cNvPr id="4" name="Text 2"/>
+          <p:cNvSpPr/>
+          <p:nvPr/>
+        </p:nvSpPr>
+        <p:spPr>
+          <a:xfrm>
+            <a:off x="502920" y="256032"/>
+            <a:ext cx="3657600" cy="457200"/>
+          </a:xfrm>
+          <a:prstGeom prst="rect">
+            <a:avLst/>
+          </a:prstGeom>
+          <a:noFill/>
+          <a:ln/>
+        </p:spPr>
+        <p:txBody>
+          <a:bodyPr wrap="square" lIns="0" tIns="0" rIns="0" bIns="0" rtlCol="0" anchor="ctr"/>
+          <a:lstStyle/>
+          <a:p>
+            <a:pPr indent="0" marL="0">
+              <a:buNone/>
+            </a:pPr>
+            <a:r>
+              <a:rPr lang="en-US" sz="2000" b="1" dirty="0">
+                <a:solidFill>
+                  <a:srgbClr val="FFFFFF"/>
+                </a:solidFill>
+                <a:latin typeface="Helvetica" pitchFamily="34" charset="0"/>
+                <a:ea typeface="Helvetica" pitchFamily="34" charset="-122"/>
+                <a:cs typeface="Helvetica" pitchFamily="34" charset="-120"/>
+              </a:rPr>
+              <a:t>belajar</a:t>
+            </a:r>
+            <a:pPr indent="0" marL="0">
+              <a:buNone/>
+            </a:pPr>
+            <a:r>
+              <a:rPr lang="en-US" sz="2000" b="1" dirty="0">
+                <a:solidFill>
+                  <a:srgbClr val="8B7CF6"/>
+                </a:solidFill>
+                <a:latin typeface="Helvetica" pitchFamily="34" charset="0"/>
+                <a:ea typeface="Helvetica" pitchFamily="34" charset="-122"/>
+                <a:cs typeface="Helvetica" pitchFamily="34" charset="-120"/>
+              </a:rPr>
+              <a:t>claude</a:t>
+            </a:r>
+            <a:endParaRPr lang="en-US" sz="2000" dirty="0"/>
+          </a:p>
+        </p:txBody>
+      </p:sp>
+      <p:sp>
+        <p:nvSpPr>
+          <p:cNvPr id="5" name="Text 3"/>
+          <p:cNvSpPr/>
+          <p:nvPr/>
+        </p:nvSpPr>
+        <p:spPr>
+          <a:xfrm>
+            <a:off x="5943600" y="274320"/>
+            <a:ext cx="5760720" cy="411480"/>
+          </a:xfrm>
+          <a:prstGeom prst="rect">
+            <a:avLst/>
+          </a:prstGeom>
+          <a:noFill/>
+          <a:ln/>
+        </p:spPr>
+        <p:txBody>
+          <a:bodyPr wrap="square" lIns="0" tIns="0" rIns="0" bIns="0" rtlCol="0" anchor="ctr"/>
+          <a:lstStyle/>
+          <a:p>
+            <a:pPr algn="r" indent="0" marL="0">
+              <a:buNone/>
+            </a:pPr>
+            <a:r>
+              <a:rPr lang="en-US" sz="1250" dirty="0">
+                <a:solidFill>
+                  <a:srgbClr val="9AA2B4"/>
+                </a:solidFill>
+                <a:latin typeface="Helvetica" pitchFamily="34" charset="0"/>
+                <a:ea typeface="Helvetica" pitchFamily="34" charset="-122"/>
+                <a:cs typeface="Helvetica" pitchFamily="34" charset="-120"/>
+              </a:rPr>
+              <a:t>Modul 07 — Dokumen &amp; Riset</a:t>
+            </a:r>
+            <a:endParaRPr lang="en-US" sz="1250" dirty="0"/>
+          </a:p>
+        </p:txBody>
+      </p:sp>
+      <p:sp>
+        <p:nvSpPr>
+          <p:cNvPr id="6" name="Text 4"/>
+          <p:cNvSpPr/>
+          <p:nvPr/>
+        </p:nvSpPr>
+        <p:spPr>
+          <a:xfrm>
+            <a:off x="548640" y="1188720"/>
+            <a:ext cx="11064240" cy="502920"/>
+          </a:xfrm>
+          <a:prstGeom prst="rect">
+            <a:avLst/>
+          </a:prstGeom>
+          <a:noFill/>
+          <a:ln/>
+        </p:spPr>
+        <p:txBody>
+          <a:bodyPr wrap="square" lIns="0" tIns="0" rIns="0" bIns="0" rtlCol="0" anchor="ctr"/>
+          <a:lstStyle/>
+          <a:p>
+            <a:pPr indent="0" marL="0">
+              <a:buNone/>
+            </a:pPr>
+            <a:r>
+              <a:rPr lang="en-US" sz="2200" b="1" dirty="0">
+                <a:solidFill>
+                  <a:srgbClr val="0D1321"/>
+                </a:solidFill>
+                <a:latin typeface="Helvetica" pitchFamily="34" charset="0"/>
+                <a:ea typeface="Helvetica" pitchFamily="34" charset="-122"/>
+                <a:cs typeface="Helvetica" pitchFamily="34" charset="-120"/>
+              </a:rPr>
+              <a:t>Latihan &amp; Output</a:t>
+            </a:r>
+            <a:endParaRPr lang="en-US" sz="2200" dirty="0"/>
+          </a:p>
+        </p:txBody>
+      </p:sp>
+      <p:sp>
+        <p:nvSpPr>
+          <p:cNvPr id="7" name="Text 5"/>
+          <p:cNvSpPr/>
+          <p:nvPr/>
+        </p:nvSpPr>
+        <p:spPr>
+          <a:xfrm>
+            <a:off x="548640" y="1783080"/>
+            <a:ext cx="11094415" cy="274320"/>
+          </a:xfrm>
+          <a:prstGeom prst="rect">
+            <a:avLst/>
+          </a:prstGeom>
+          <a:noFill/>
+          <a:ln/>
+        </p:spPr>
+        <p:txBody>
+          <a:bodyPr wrap="square" lIns="0" tIns="0" rIns="0" bIns="0" rtlCol="0" anchor="ctr"/>
+          <a:lstStyle/>
+          <a:p>
+            <a:pPr indent="0" marL="0">
+              <a:buNone/>
+            </a:pPr>
+            <a:r>
+              <a:rPr lang="en-US" sz="1250" b="1" spc="40" kern="0" dirty="0">
+                <a:solidFill>
+                  <a:srgbClr val="4B36C7"/>
+                </a:solidFill>
+                <a:latin typeface="Helvetica" pitchFamily="34" charset="0"/>
+                <a:ea typeface="Helvetica" pitchFamily="34" charset="-122"/>
+                <a:cs typeface="Helvetica" pitchFamily="34" charset="-120"/>
+              </a:rPr>
+              <a:t>PRAKTIKKAN KEEMPAT SKILL DI KERJAANMU SENDIRI</a:t>
+            </a:r>
+            <a:endParaRPr lang="en-US" sz="1250" dirty="0"/>
+          </a:p>
+        </p:txBody>
+      </p:sp>
+      <p:sp>
+        <p:nvSpPr>
+          <p:cNvPr id="8" name="Shape 6"/>
+          <p:cNvSpPr/>
+          <p:nvPr/>
+        </p:nvSpPr>
+        <p:spPr>
+          <a:xfrm>
+            <a:off x="548640" y="2112264"/>
+            <a:ext cx="11094415" cy="1480376"/>
+          </a:xfrm>
+          <a:prstGeom prst="roundRect">
+            <a:avLst>
+              <a:gd name="adj" fmla="val 6177"/>
+            </a:avLst>
+          </a:prstGeom>
+          <a:solidFill>
+            <a:srgbClr val="EAFAF0"/>
+          </a:solidFill>
+          <a:ln w="12700">
+            <a:solidFill>
+              <a:srgbClr val="B8E6C9"/>
+            </a:solidFill>
+            <a:prstDash val="solid"/>
+          </a:ln>
+        </p:spPr>
+      </p:sp>
+      <p:sp>
+        <p:nvSpPr>
+          <p:cNvPr id="9" name="Text 7"/>
+          <p:cNvSpPr/>
+          <p:nvPr/>
+        </p:nvSpPr>
+        <p:spPr>
+          <a:xfrm>
+            <a:off x="749808" y="2313432"/>
+            <a:ext cx="10692079" cy="274320"/>
+          </a:xfrm>
+          <a:prstGeom prst="rect">
+            <a:avLst/>
+          </a:prstGeom>
+          <a:noFill/>
+          <a:ln/>
+        </p:spPr>
+        <p:txBody>
+          <a:bodyPr wrap="square" lIns="0" tIns="0" rIns="0" bIns="0" rtlCol="0" anchor="ctr"/>
+          <a:lstStyle/>
+          <a:p>
+            <a:pPr indent="0" marL="0">
+              <a:buNone/>
+            </a:pPr>
+            <a:r>
+              <a:rPr lang="en-US" sz="1250" b="1" spc="30" kern="0" dirty="0">
+                <a:solidFill>
+                  <a:srgbClr val="1A7A44"/>
+                </a:solidFill>
+                <a:latin typeface="Helvetica" pitchFamily="34" charset="0"/>
+                <a:ea typeface="Helvetica" pitchFamily="34" charset="-122"/>
+                <a:cs typeface="Helvetica" pitchFamily="34" charset="-120"/>
+              </a:rPr>
+              <a:t>■  LATIHAN</a:t>
+            </a:r>
+            <a:endParaRPr lang="en-US" sz="1250" dirty="0"/>
+          </a:p>
+        </p:txBody>
+      </p:sp>
+      <p:sp>
+        <p:nvSpPr>
+          <p:cNvPr id="10" name="Text 8"/>
+          <p:cNvSpPr/>
+          <p:nvPr/>
+        </p:nvSpPr>
+        <p:spPr>
+          <a:xfrm>
+            <a:off x="749808" y="2660904"/>
+            <a:ext cx="10692079" cy="730568"/>
+          </a:xfrm>
+          <a:prstGeom prst="rect">
+            <a:avLst/>
+          </a:prstGeom>
+          <a:noFill/>
+          <a:ln/>
+        </p:spPr>
+        <p:txBody>
+          <a:bodyPr wrap="square" lIns="0" tIns="0" rIns="0" bIns="0" rtlCol="0" anchor="t"/>
+          <a:lstStyle/>
+          <a:p>
+            <a:pPr indent="0" marL="0">
+              <a:lnSpc>
+                <a:spcPct val="130000"/>
+              </a:lnSpc>
+              <a:buNone/>
+            </a:pPr>
+            <a:r>
+              <a:rPr lang="en-US" sz="1250" dirty="0">
+                <a:solidFill>
+                  <a:srgbClr val="23283A"/>
+                </a:solidFill>
+                <a:latin typeface="Helvetica" pitchFamily="34" charset="0"/>
+                <a:ea typeface="Helvetica" pitchFamily="34" charset="-122"/>
+                <a:cs typeface="Helvetica" pitchFamily="34" charset="-120"/>
+              </a:rPr>
+              <a:t>Ambil 1 catatan rapat terakhir → minta action items. Pilih 1 dokumen yang "menunggu" dibaca → minta ringkasan sesuai keputusan yang perlu kamu buat. Jelaskan 1 keputusan bisnis yang dipertimbangkan → minta SWOT, lalu ubah jadi slide presentasi. Ceritakan 1 proses kerja → minta SOP.</a:t>
+            </a:r>
+            <a:endParaRPr lang="en-US" sz="1250" dirty="0"/>
+          </a:p>
+        </p:txBody>
+      </p:sp>
+      <p:sp>
+        <p:nvSpPr>
+          <p:cNvPr id="11" name="Shape 9"/>
+          <p:cNvSpPr/>
+          <p:nvPr/>
+        </p:nvSpPr>
+        <p:spPr>
+          <a:xfrm>
+            <a:off x="548640" y="3830384"/>
+            <a:ext cx="11094415" cy="993331"/>
+          </a:xfrm>
+          <a:prstGeom prst="roundRect">
+            <a:avLst>
+              <a:gd name="adj" fmla="val 9205"/>
+            </a:avLst>
+          </a:prstGeom>
+          <a:solidFill>
+            <a:srgbClr val="EAFAF0"/>
+          </a:solidFill>
+          <a:ln w="12700">
+            <a:solidFill>
+              <a:srgbClr val="B8E6C9"/>
+            </a:solidFill>
+            <a:prstDash val="solid"/>
+          </a:ln>
+        </p:spPr>
+      </p:sp>
+      <p:sp>
+        <p:nvSpPr>
+          <p:cNvPr id="12" name="Text 10"/>
+          <p:cNvSpPr/>
+          <p:nvPr/>
+        </p:nvSpPr>
+        <p:spPr>
+          <a:xfrm>
+            <a:off x="749808" y="4031552"/>
+            <a:ext cx="10692079" cy="274320"/>
+          </a:xfrm>
+          <a:prstGeom prst="rect">
+            <a:avLst/>
+          </a:prstGeom>
+          <a:noFill/>
+          <a:ln/>
+        </p:spPr>
+        <p:txBody>
+          <a:bodyPr wrap="square" lIns="0" tIns="0" rIns="0" bIns="0" rtlCol="0" anchor="ctr"/>
+          <a:lstStyle/>
+          <a:p>
+            <a:pPr indent="0" marL="0">
+              <a:buNone/>
+            </a:pPr>
+            <a:r>
+              <a:rPr lang="en-US" sz="1250" b="1" spc="30" kern="0" dirty="0">
+                <a:solidFill>
+                  <a:srgbClr val="1A7A44"/>
+                </a:solidFill>
+                <a:latin typeface="Helvetica" pitchFamily="34" charset="0"/>
+                <a:ea typeface="Helvetica" pitchFamily="34" charset="-122"/>
+                <a:cs typeface="Helvetica" pitchFamily="34" charset="-120"/>
+              </a:rPr>
+              <a:t>■  OUTPUT</a:t>
+            </a:r>
+            <a:endParaRPr lang="en-US" sz="1250" dirty="0"/>
+          </a:p>
+        </p:txBody>
+      </p:sp>
+      <p:sp>
+        <p:nvSpPr>
+          <p:cNvPr id="13" name="Text 11"/>
+          <p:cNvSpPr/>
+          <p:nvPr/>
+        </p:nvSpPr>
+        <p:spPr>
+          <a:xfrm>
+            <a:off x="749808" y="4379024"/>
+            <a:ext cx="10692079" cy="243523"/>
+          </a:xfrm>
+          <a:prstGeom prst="rect">
+            <a:avLst/>
+          </a:prstGeom>
+          <a:noFill/>
+          <a:ln/>
+        </p:spPr>
+        <p:txBody>
+          <a:bodyPr wrap="square" lIns="0" tIns="0" rIns="0" bIns="0" rtlCol="0" anchor="t"/>
+          <a:lstStyle/>
+          <a:p>
+            <a:pPr indent="0" marL="0">
+              <a:lnSpc>
+                <a:spcPct val="130000"/>
+              </a:lnSpc>
+              <a:buNone/>
+            </a:pPr>
+            <a:r>
+              <a:rPr lang="en-US" sz="1250" dirty="0">
+                <a:solidFill>
+                  <a:srgbClr val="23283A"/>
+                </a:solidFill>
+                <a:latin typeface="Helvetica" pitchFamily="34" charset="0"/>
+                <a:ea typeface="Helvetica" pitchFamily="34" charset="-122"/>
+                <a:cs typeface="Helvetica" pitchFamily="34" charset="-120"/>
+              </a:rPr>
+              <a:t>4 output siap pakai: tabel action items, ringkasan dokumen, SWOT 1 halaman, dan 1 SOP untuk pegawai baru.</a:t>
+            </a:r>
+            <a:endParaRPr lang="en-US" sz="1250" dirty="0"/>
+          </a:p>
+        </p:txBody>
+      </p:sp>
+    </p:spTree>
+  </p:cSld>
+  <p:clrMapOvr>
+    <a:masterClrMapping/>
+  </p:clrMapOvr>
+</p:sld>
+</file>
+
+<file path=ppt/slides/slide8.xml><?xml version="1.0" encoding="utf-8"?>
+<p:sld xmlns:a="http://schemas.openxmlformats.org/drawingml/2006/main" xmlns:r="http://schemas.openxmlformats.org/officeDocument/2006/relationships" xmlns:p="http://schemas.openxmlformats.org/presentationml/2006/main">
+  <p:cSld name="Slide 8">
     <p:bg>
       <p:bgPr>
         <a:solidFill>

</xml_diff>

<commit_message>
M7: fix inaccurate Claude web-browsing claim in SWOT section (HTML+PDF+PPT); CONTEXT.md checkpoint 28
</commit_message>
<xml_diff>
--- a/K2-Produktivitas/M07-Dokumen-Riset/K2-M07-Dokumen-Riset.pptx
+++ b/K2-Produktivitas/M07-Dokumen-Riset/K2-M07-Dokumen-Riset.pptx
@@ -4445,11 +4445,11 @@
         <p:spPr>
           <a:xfrm>
             <a:off x="548640" y="2112264"/>
-            <a:ext cx="5410048" cy="2206447"/>
+            <a:ext cx="5410048" cy="2449220"/>
           </a:xfrm>
           <a:prstGeom prst="roundRect">
             <a:avLst>
-              <a:gd name="adj" fmla="val 4144"/>
+              <a:gd name="adj" fmla="val 3733"/>
             </a:avLst>
           </a:prstGeom>
           <a:solidFill>
@@ -4511,7 +4511,7 @@
         <p:spPr>
           <a:xfrm>
             <a:off x="749808" y="2660904"/>
-            <a:ext cx="5007712" cy="1456639"/>
+            <a:ext cx="5007712" cy="1699412"/>
           </a:xfrm>
           <a:prstGeom prst="rect">
             <a:avLst/>
@@ -4538,7 +4538,7 @@
                 <a:ea typeface="Helvetica" pitchFamily="34" charset="-122"/>
                 <a:cs typeface="Helvetica" pitchFamily="34" charset="-120"/>
               </a:rPr>
-              <a:t>•  Claude tidak browsing internet real-time — kamu bawa observasi, Claude bantu menganalisis dan menyusun</a:t>
+              <a:t>•  Analisis paling tajam datang dari observasi langsungmu, bukan pencarian umum — kamu bawa observasi, Claude bantu menganalisis dan menyusun</a:t>
             </a:r>
             <a:endParaRPr lang="en-US" sz="1200" dirty="0"/>
           </a:p>
@@ -4593,11 +4593,11 @@
         <p:spPr>
           <a:xfrm>
             <a:off x="6233008" y="2112264"/>
-            <a:ext cx="5410048" cy="2206447"/>
+            <a:ext cx="5410048" cy="2449220"/>
           </a:xfrm>
           <a:prstGeom prst="roundRect">
             <a:avLst>
-              <a:gd name="adj" fmla="val 4144"/>
+              <a:gd name="adj" fmla="val 3733"/>
             </a:avLst>
           </a:prstGeom>
           <a:solidFill>
@@ -4659,7 +4659,7 @@
         <p:spPr>
           <a:xfrm>
             <a:off x="6434176" y="2660904"/>
-            <a:ext cx="5007712" cy="1456639"/>
+            <a:ext cx="5007712" cy="1699412"/>
           </a:xfrm>
           <a:prstGeom prst="rect">
             <a:avLst/>

</xml_diff>

<commit_message>
M7: add web-search research section (HTML+PDF+PPT); CONTEXT.md checkpoint 29
</commit_message>
<xml_diff>
--- a/K2-Produktivitas/M07-Dokumen-Riset/K2-M07-Dokumen-Riset.pptx
+++ b/K2-Produktivitas/M07-Dokumen-Riset/K2-M07-Dokumen-Riset.pptx
@@ -13,9 +13,10 @@
     <p:sldId id="261" r:id="rId7"/>
     <p:sldId id="262" r:id="rId8"/>
     <p:sldId id="263" r:id="rId9"/>
+    <p:sldId id="264" r:id="rId10"/>
   </p:sldIdLst>
   <p:notesMasterIdLst>
-    <p:notesMasterId r:id="rId10"/>
+    <p:notesMasterId r:id="rId11"/>
   </p:notesMasterIdLst>
   <p:sldSz cx="12191695" cy="6858000"/>
   <p:notesSz cx="6858000" cy="12191695"/>
@@ -1149,6 +1150,94 @@
             <a:fld id="{F7021451-1387-4CA6-816F-3879F97B5CBC}" type="slidenum">
               <a:rPr lang="en-US"/>
               <a:t>8</a:t>
+            </a:fld>
+            <a:endParaRPr lang="en-US"/>
+          </a:p>
+        </p:txBody>
+      </p:sp>
+    </p:spTree>
+    <p:extLst>
+      <p:ext uri="{BB962C8B-B14F-4D97-AF65-F5344CB8AC3E}">
+        <p14:creationId xmlns:p14="http://schemas.microsoft.com/office/powerpoint/2010/main" val="1024086991"/>
+      </p:ext>
+    </p:extLst>
+  </p:cSld>
+  <p:clrMapOvr>
+    <a:masterClrMapping/>
+  </p:clrMapOvr>
+</p:notes>
+</file>
+
+<file path=ppt/notesSlides/notesSlide9.xml><?xml version="1.0" encoding="utf-8"?>
+<p:notes xmlns:a="http://schemas.openxmlformats.org/drawingml/2006/main" xmlns:r="http://schemas.openxmlformats.org/officeDocument/2006/relationships" xmlns:p="http://schemas.openxmlformats.org/presentationml/2006/main">
+  <p:cSld>
+    <p:spTree>
+      <p:nvGrpSpPr>
+        <p:cNvPr id="1" name=""/>
+        <p:cNvGrpSpPr/>
+        <p:nvPr/>
+      </p:nvGrpSpPr>
+      <p:grpSpPr>
+        <a:xfrm>
+          <a:off x="0" y="0"/>
+          <a:ext cx="0" cy="0"/>
+          <a:chOff x="0" y="0"/>
+          <a:chExt cx="0" cy="0"/>
+        </a:xfrm>
+      </p:grpSpPr>
+      <p:sp>
+        <p:nvSpPr>
+          <p:cNvPr id="2" name="Slide Image Placeholder 1"/>
+          <p:cNvSpPr>
+            <a:spLocks noGrp="1" noRot="1" noChangeAspect="1"/>
+          </p:cNvSpPr>
+          <p:nvPr>
+            <p:ph type="sldImg"/>
+          </p:nvPr>
+        </p:nvSpPr>
+        <p:spPr/>
+      </p:sp>
+      <p:sp>
+        <p:nvSpPr>
+          <p:cNvPr id="3" name="Notes Placeholder 2"/>
+          <p:cNvSpPr>
+            <a:spLocks noGrp="1"/>
+          </p:cNvSpPr>
+          <p:nvPr>
+            <p:ph type="body" idx="1"/>
+          </p:nvPr>
+        </p:nvSpPr>
+        <p:spPr/>
+        <p:txBody>
+          <a:bodyPr/>
+          <a:lstStyle/>
+          <a:p>
+            <a:r>
+              <a:rPr lang="en-US" dirty="0"/>
+              <a:t/>
+            </a:r>
+            <a:endParaRPr lang="en-US" dirty="0"/>
+          </a:p>
+        </p:txBody>
+      </p:sp>
+      <p:sp>
+        <p:nvSpPr>
+          <p:cNvPr id="4" name="Slide Number Placeholder 3"/>
+          <p:cNvSpPr>
+            <a:spLocks noGrp="1"/>
+          </p:cNvSpPr>
+          <p:nvPr>
+            <p:ph type="sldNum" sz="quarter" idx="10"/>
+          </p:nvPr>
+        </p:nvSpPr>
+        <p:spPr/>
+        <p:txBody>
+          <a:bodyPr/>
+          <a:lstStyle/>
+          <a:p>
+            <a:fld id="{F7021451-1387-4CA6-816F-3879F97B5CBC}" type="slidenum">
+              <a:rPr lang="en-US"/>
+              <a:t>9</a:t>
             </a:fld>
             <a:endParaRPr lang="en-US"/>
           </a:p>
@@ -4929,7 +5018,7 @@
                 <a:ea typeface="Helvetica" pitchFamily="34" charset="-122"/>
                 <a:cs typeface="Helvetica" pitchFamily="34" charset="-120"/>
               </a:rPr>
-              <a:t>SWOT → Slide Presentasi</a:t>
+              <a:t>Perkuat Riset dengan Web Search</a:t>
             </a:r>
             <a:endParaRPr lang="en-US" sz="2200" dirty="0"/>
           </a:p>
@@ -5010,7 +5099,7 @@
                 <a:ea typeface="Helvetica" pitchFamily="34" charset="-122"/>
                 <a:cs typeface="Helvetica" pitchFamily="34" charset="-120"/>
               </a:rPr>
-              <a:t>SWOT atau riset yang sudah kamu buat biasanya perlu dipresentasikan — ke partner bisnis, calon investor, atau tim internal. Daripada mengetik ulang manual di PowerPoint, minta Claude langsung susun jadi slide.</a:t>
+              <a:t>Observasi langsungmu tetap paling tajam untuk detail spesifik bisnismu — tapi kalau Claude-mu punya fitur web search aktif, minta Claude cari info terkini untuk melengkapi: tren pasar, berita industri, atau data publik kompetitor.</a:t>
             </a:r>
             <a:endParaRPr lang="en-US" sz="1300" dirty="0"/>
           </a:p>
@@ -5025,11 +5114,11 @@
         <p:spPr>
           <a:xfrm>
             <a:off x="548640" y="2848742"/>
-            <a:ext cx="11094415" cy="1429283"/>
+            <a:ext cx="11094415" cy="1214984"/>
           </a:xfrm>
           <a:prstGeom prst="roundRect">
             <a:avLst>
-              <a:gd name="adj" fmla="val 6398"/>
+              <a:gd name="adj" fmla="val 7526"/>
             </a:avLst>
           </a:prstGeom>
           <a:solidFill>
@@ -5091,7 +5180,7 @@
         <p:spPr>
           <a:xfrm>
             <a:off x="768096" y="3415670"/>
-            <a:ext cx="10655503" cy="642899"/>
+            <a:ext cx="10655503" cy="428600"/>
           </a:xfrm>
           <a:prstGeom prst="rect">
             <a:avLst/>
@@ -5118,7 +5207,7 @@
                 <a:ea typeface="Helvetica" pitchFamily="34" charset="-122"/>
                 <a:cs typeface="Helvetica" pitchFamily="34" charset="-120"/>
               </a:rPr>
-              <a:t>Dari SWOT tas kanvas yang sudah kita buat tadi, buatkan sebagai file presentasi (.pptx): 1 slide judul, lalu 1 slide per kuadran dengan judul singkat dan 3-4 bullet point per slide, dan 1 slide kesimpulan dengan rekomendasi. Desain simpel dan rapi, siap dipakai presentasi atau dipoles lebih lanjut di PowerPoint atau Google Slides.</a:t>
+              <a:t>Cari informasi terbaru soal tren pasar tas kanvas casual di Indonesia tahun ini, dan data publik tentang kompetitor seperti Kanvas Kita atau Totewear.id. Bandingkan dengan observasiku di SWOT tadi — ada yang perlu ditambahkan?</a:t>
             </a:r>
             <a:endParaRPr lang="en-US" sz="1100" dirty="0"/>
           </a:p>
@@ -5132,7 +5221,7 @@
         </p:nvSpPr>
         <p:spPr>
           <a:xfrm>
-            <a:off x="548640" y="4515769"/>
+            <a:off x="548640" y="4301470"/>
             <a:ext cx="11094415" cy="479552"/>
           </a:xfrm>
           <a:prstGeom prst="rect">
@@ -5160,7 +5249,7 @@
                 <a:ea typeface="Helvetica" pitchFamily="34" charset="-122"/>
                 <a:cs typeface="Helvetica" pitchFamily="34" charset="-120"/>
               </a:rPr>
-              <a:t>Belum bisa bikin file langsung? Prompt yang sama tetap menghasilkan teks terstruktur per slide — tinggal copy-paste manual ke PowerPoint atau Google Slides.</a:t>
+              <a:t>Web search melengkapi gambaran besar, bukan pengganti observasi lapanganmu. Belum ada web search? Cari manual di Google, paste hasilnya ke Claude.</a:t>
             </a:r>
             <a:endParaRPr lang="en-US" sz="1250" dirty="0"/>
           </a:p>
@@ -5363,7 +5452,7 @@
                 <a:ea typeface="Helvetica" pitchFamily="34" charset="-122"/>
                 <a:cs typeface="Helvetica" pitchFamily="34" charset="-120"/>
               </a:rPr>
-              <a:t>Latihan &amp; Output</a:t>
+              <a:t>SWOT → Slide Presentasi</a:t>
             </a:r>
             <a:endParaRPr lang="en-US" sz="2200" dirty="0"/>
           </a:p>
@@ -5402,7 +5491,7 @@
                 <a:ea typeface="Helvetica" pitchFamily="34" charset="-122"/>
                 <a:cs typeface="Helvetica" pitchFamily="34" charset="-120"/>
               </a:rPr>
-              <a:t>PRAKTIKKAN KEEMPAT SKILL DI KERJAANMU SENDIRI</a:t>
+              <a:t>KAPAN DIPAKAI</a:t>
             </a:r>
             <a:endParaRPr lang="en-US" sz="1250" dirty="0"/>
           </a:p>
@@ -5410,26 +5499,68 @@
       </p:sp>
       <p:sp>
         <p:nvSpPr>
-          <p:cNvPr id="8" name="Shape 6"/>
+          <p:cNvPr id="8" name="Text 6"/>
           <p:cNvSpPr/>
           <p:nvPr/>
         </p:nvSpPr>
         <p:spPr>
           <a:xfrm>
             <a:off x="548640" y="2112264"/>
-            <a:ext cx="11094415" cy="1480376"/>
+            <a:ext cx="11094415" cy="498734"/>
+          </a:xfrm>
+          <a:prstGeom prst="rect">
+            <a:avLst/>
+          </a:prstGeom>
+          <a:noFill/>
+          <a:ln/>
+        </p:spPr>
+        <p:txBody>
+          <a:bodyPr wrap="square" lIns="0" tIns="0" rIns="0" bIns="0" rtlCol="0" anchor="t"/>
+          <a:lstStyle/>
+          <a:p>
+            <a:pPr indent="0" marL="0">
+              <a:lnSpc>
+                <a:spcPct val="128000"/>
+              </a:lnSpc>
+              <a:buNone/>
+            </a:pPr>
+            <a:r>
+              <a:rPr lang="en-US" sz="1300" dirty="0">
+                <a:solidFill>
+                  <a:srgbClr val="23283A"/>
+                </a:solidFill>
+                <a:latin typeface="Helvetica" pitchFamily="34" charset="0"/>
+                <a:ea typeface="Helvetica" pitchFamily="34" charset="-122"/>
+                <a:cs typeface="Helvetica" pitchFamily="34" charset="-120"/>
+              </a:rPr>
+              <a:t>SWOT atau riset yang sudah kamu buat biasanya perlu dipresentasikan — ke partner bisnis, calon investor, atau tim internal. Daripada mengetik ulang manual di PowerPoint, minta Claude langsung susun jadi slide.</a:t>
+            </a:r>
+            <a:endParaRPr lang="en-US" sz="1300" dirty="0"/>
+          </a:p>
+        </p:txBody>
+      </p:sp>
+      <p:sp>
+        <p:nvSpPr>
+          <p:cNvPr id="9" name="Shape 7"/>
+          <p:cNvSpPr/>
+          <p:nvPr/>
+        </p:nvSpPr>
+        <p:spPr>
+          <a:xfrm>
+            <a:off x="548640" y="2848742"/>
+            <a:ext cx="11094415" cy="1429283"/>
           </a:xfrm>
           <a:prstGeom prst="roundRect">
             <a:avLst>
-              <a:gd name="adj" fmla="val 6177"/>
+              <a:gd name="adj" fmla="val 6398"/>
             </a:avLst>
           </a:prstGeom>
           <a:solidFill>
-            <a:srgbClr val="EAFAF0"/>
+            <a:srgbClr val="141D33"/>
           </a:solidFill>
           <a:ln w="12700">
             <a:solidFill>
-              <a:srgbClr val="B8E6C9"/>
+              <a:srgbClr val="6849F6"/>
             </a:solidFill>
             <a:prstDash val="solid"/>
           </a:ln>
@@ -5437,14 +5568,14 @@
       </p:sp>
       <p:sp>
         <p:nvSpPr>
-          <p:cNvPr id="9" name="Text 7"/>
-          <p:cNvSpPr/>
-          <p:nvPr/>
-        </p:nvSpPr>
-        <p:spPr>
-          <a:xfrm>
-            <a:off x="749808" y="2313432"/>
-            <a:ext cx="10692079" cy="274320"/>
+          <p:cNvPr id="10" name="Text 8"/>
+          <p:cNvSpPr/>
+          <p:nvPr/>
+        </p:nvSpPr>
+        <p:spPr>
+          <a:xfrm>
+            <a:off x="768096" y="3068198"/>
+            <a:ext cx="10655503" cy="256032"/>
           </a:xfrm>
           <a:prstGeom prst="rect">
             <a:avLst/>
@@ -5460,30 +5591,30 @@
               <a:buNone/>
             </a:pPr>
             <a:r>
-              <a:rPr lang="en-US" sz="1250" b="1" spc="30" kern="0" dirty="0">
-                <a:solidFill>
-                  <a:srgbClr val="1A7A44"/>
-                </a:solidFill>
-                <a:latin typeface="Helvetica" pitchFamily="34" charset="0"/>
-                <a:ea typeface="Helvetica" pitchFamily="34" charset="-122"/>
-                <a:cs typeface="Helvetica" pitchFamily="34" charset="-120"/>
-              </a:rPr>
-              <a:t>■  LATIHAN</a:t>
-            </a:r>
-            <a:endParaRPr lang="en-US" sz="1250" dirty="0"/>
-          </a:p>
-        </p:txBody>
-      </p:sp>
-      <p:sp>
-        <p:nvSpPr>
-          <p:cNvPr id="10" name="Text 8"/>
-          <p:cNvSpPr/>
-          <p:nvPr/>
-        </p:nvSpPr>
-        <p:spPr>
-          <a:xfrm>
-            <a:off x="749808" y="2660904"/>
-            <a:ext cx="10692079" cy="730568"/>
+              <a:rPr lang="en-US" sz="1150" b="1" spc="30" kern="0" dirty="0">
+                <a:solidFill>
+                  <a:srgbClr val="8B7CF6"/>
+                </a:solidFill>
+                <a:latin typeface="Helvetica" pitchFamily="34" charset="0"/>
+                <a:ea typeface="Helvetica" pitchFamily="34" charset="-122"/>
+                <a:cs typeface="Helvetica" pitchFamily="34" charset="-120"/>
+              </a:rPr>
+              <a:t>PROMPT</a:t>
+            </a:r>
+            <a:endParaRPr lang="en-US" sz="1150" dirty="0"/>
+          </a:p>
+        </p:txBody>
+      </p:sp>
+      <p:sp>
+        <p:nvSpPr>
+          <p:cNvPr id="11" name="Text 9"/>
+          <p:cNvSpPr/>
+          <p:nvPr/>
+        </p:nvSpPr>
+        <p:spPr>
+          <a:xfrm>
+            <a:off x="768096" y="3415670"/>
+            <a:ext cx="10655503" cy="642899"/>
           </a:xfrm>
           <a:prstGeom prst="rect">
             <a:avLst/>
@@ -5502,123 +5633,57 @@
               <a:buNone/>
             </a:pPr>
             <a:r>
+              <a:rPr lang="en-US" sz="1100" dirty="0">
+                <a:solidFill>
+                  <a:srgbClr val="C7CDE0"/>
+                </a:solidFill>
+                <a:latin typeface="Helvetica" pitchFamily="34" charset="0"/>
+                <a:ea typeface="Helvetica" pitchFamily="34" charset="-122"/>
+                <a:cs typeface="Helvetica" pitchFamily="34" charset="-120"/>
+              </a:rPr>
+              <a:t>Dari SWOT tas kanvas yang sudah kita buat tadi, buatkan sebagai file presentasi (.pptx): 1 slide judul, lalu 1 slide per kuadran dengan judul singkat dan 3-4 bullet point per slide, dan 1 slide kesimpulan dengan rekomendasi. Desain simpel dan rapi, siap dipakai presentasi atau dipoles lebih lanjut di PowerPoint atau Google Slides.</a:t>
+            </a:r>
+            <a:endParaRPr lang="en-US" sz="1100" dirty="0"/>
+          </a:p>
+        </p:txBody>
+      </p:sp>
+      <p:sp>
+        <p:nvSpPr>
+          <p:cNvPr id="12" name="Text 10"/>
+          <p:cNvSpPr/>
+          <p:nvPr/>
+        </p:nvSpPr>
+        <p:spPr>
+          <a:xfrm>
+            <a:off x="548640" y="4515769"/>
+            <a:ext cx="11094415" cy="479552"/>
+          </a:xfrm>
+          <a:prstGeom prst="rect">
+            <a:avLst/>
+          </a:prstGeom>
+          <a:noFill/>
+          <a:ln/>
+        </p:spPr>
+        <p:txBody>
+          <a:bodyPr wrap="square" lIns="0" tIns="0" rIns="0" bIns="0" rtlCol="0" anchor="t"/>
+          <a:lstStyle/>
+          <a:p>
+            <a:pPr indent="0" marL="0">
+              <a:lnSpc>
+                <a:spcPct val="128000"/>
+              </a:lnSpc>
+              <a:buNone/>
+            </a:pPr>
+            <a:r>
               <a:rPr lang="en-US" sz="1250" dirty="0">
                 <a:solidFill>
-                  <a:srgbClr val="23283A"/>
-                </a:solidFill>
-                <a:latin typeface="Helvetica" pitchFamily="34" charset="0"/>
-                <a:ea typeface="Helvetica" pitchFamily="34" charset="-122"/>
-                <a:cs typeface="Helvetica" pitchFamily="34" charset="-120"/>
-              </a:rPr>
-              <a:t>Ambil 1 catatan rapat terakhir → minta action items. Pilih 1 dokumen yang "menunggu" dibaca → minta ringkasan sesuai keputusan yang perlu kamu buat. Jelaskan 1 keputusan bisnis yang dipertimbangkan → minta SWOT, lalu ubah jadi slide presentasi. Ceritakan 1 proses kerja → minta SOP.</a:t>
-            </a:r>
-            <a:endParaRPr lang="en-US" sz="1250" dirty="0"/>
-          </a:p>
-        </p:txBody>
-      </p:sp>
-      <p:sp>
-        <p:nvSpPr>
-          <p:cNvPr id="11" name="Shape 9"/>
-          <p:cNvSpPr/>
-          <p:nvPr/>
-        </p:nvSpPr>
-        <p:spPr>
-          <a:xfrm>
-            <a:off x="548640" y="3830384"/>
-            <a:ext cx="11094415" cy="993331"/>
-          </a:xfrm>
-          <a:prstGeom prst="roundRect">
-            <a:avLst>
-              <a:gd name="adj" fmla="val 9205"/>
-            </a:avLst>
-          </a:prstGeom>
-          <a:solidFill>
-            <a:srgbClr val="EAFAF0"/>
-          </a:solidFill>
-          <a:ln w="12700">
-            <a:solidFill>
-              <a:srgbClr val="B8E6C9"/>
-            </a:solidFill>
-            <a:prstDash val="solid"/>
-          </a:ln>
-        </p:spPr>
-      </p:sp>
-      <p:sp>
-        <p:nvSpPr>
-          <p:cNvPr id="12" name="Text 10"/>
-          <p:cNvSpPr/>
-          <p:nvPr/>
-        </p:nvSpPr>
-        <p:spPr>
-          <a:xfrm>
-            <a:off x="749808" y="4031552"/>
-            <a:ext cx="10692079" cy="274320"/>
-          </a:xfrm>
-          <a:prstGeom prst="rect">
-            <a:avLst/>
-          </a:prstGeom>
-          <a:noFill/>
-          <a:ln/>
-        </p:spPr>
-        <p:txBody>
-          <a:bodyPr wrap="square" lIns="0" tIns="0" rIns="0" bIns="0" rtlCol="0" anchor="ctr"/>
-          <a:lstStyle/>
-          <a:p>
-            <a:pPr indent="0" marL="0">
-              <a:buNone/>
-            </a:pPr>
-            <a:r>
-              <a:rPr lang="en-US" sz="1250" b="1" spc="30" kern="0" dirty="0">
-                <a:solidFill>
-                  <a:srgbClr val="1A7A44"/>
-                </a:solidFill>
-                <a:latin typeface="Helvetica" pitchFamily="34" charset="0"/>
-                <a:ea typeface="Helvetica" pitchFamily="34" charset="-122"/>
-                <a:cs typeface="Helvetica" pitchFamily="34" charset="-120"/>
-              </a:rPr>
-              <a:t>■  OUTPUT</a:t>
-            </a:r>
-            <a:endParaRPr lang="en-US" sz="1250" dirty="0"/>
-          </a:p>
-        </p:txBody>
-      </p:sp>
-      <p:sp>
-        <p:nvSpPr>
-          <p:cNvPr id="13" name="Text 11"/>
-          <p:cNvSpPr/>
-          <p:nvPr/>
-        </p:nvSpPr>
-        <p:spPr>
-          <a:xfrm>
-            <a:off x="749808" y="4379024"/>
-            <a:ext cx="10692079" cy="243523"/>
-          </a:xfrm>
-          <a:prstGeom prst="rect">
-            <a:avLst/>
-          </a:prstGeom>
-          <a:noFill/>
-          <a:ln/>
-        </p:spPr>
-        <p:txBody>
-          <a:bodyPr wrap="square" lIns="0" tIns="0" rIns="0" bIns="0" rtlCol="0" anchor="t"/>
-          <a:lstStyle/>
-          <a:p>
-            <a:pPr indent="0" marL="0">
-              <a:lnSpc>
-                <a:spcPct val="130000"/>
-              </a:lnSpc>
-              <a:buNone/>
-            </a:pPr>
-            <a:r>
-              <a:rPr lang="en-US" sz="1250" dirty="0">
-                <a:solidFill>
-                  <a:srgbClr val="23283A"/>
-                </a:solidFill>
-                <a:latin typeface="Helvetica" pitchFamily="34" charset="0"/>
-                <a:ea typeface="Helvetica" pitchFamily="34" charset="-122"/>
-                <a:cs typeface="Helvetica" pitchFamily="34" charset="-120"/>
-              </a:rPr>
-              <a:t>4 output siap pakai: tabel action items, ringkasan dokumen, SWOT 1 halaman, dan 1 SOP untuk pegawai baru.</a:t>
+                  <a:srgbClr val="6B7280"/>
+                </a:solidFill>
+                <a:latin typeface="Helvetica" pitchFamily="34" charset="0"/>
+                <a:ea typeface="Helvetica" pitchFamily="34" charset="-122"/>
+                <a:cs typeface="Helvetica" pitchFamily="34" charset="-120"/>
+              </a:rPr>
+              <a:t>Belum bisa bikin file langsung? Prompt yang sama tetap menghasilkan teks terstruktur per slide — tinggal copy-paste manual ke PowerPoint atau Google Slides.</a:t>
             </a:r>
             <a:endParaRPr lang="en-US" sz="1250" dirty="0"/>
           </a:p>
@@ -5635,6 +5700,464 @@
 <file path=ppt/slides/slide8.xml><?xml version="1.0" encoding="utf-8"?>
 <p:sld xmlns:a="http://schemas.openxmlformats.org/drawingml/2006/main" xmlns:r="http://schemas.openxmlformats.org/officeDocument/2006/relationships" xmlns:p="http://schemas.openxmlformats.org/presentationml/2006/main">
   <p:cSld name="Slide 8">
+    <p:bg>
+      <p:bgPr>
+        <a:solidFill>
+          <a:srgbClr val="FFFFFF"/>
+        </a:solidFill>
+      </p:bgPr>
+    </p:bg>
+    <p:spTree>
+      <p:nvGrpSpPr>
+        <p:cNvPr id="1" name=""/>
+        <p:cNvGrpSpPr/>
+        <p:nvPr/>
+      </p:nvGrpSpPr>
+      <p:grpSpPr>
+        <a:xfrm>
+          <a:off x="0" y="0"/>
+          <a:ext cx="0" cy="0"/>
+          <a:chOff x="0" y="0"/>
+          <a:chExt cx="0" cy="0"/>
+        </a:xfrm>
+      </p:grpSpPr>
+      <p:sp>
+        <p:nvSpPr>
+          <p:cNvPr id="2" name="Shape 0"/>
+          <p:cNvSpPr/>
+          <p:nvPr/>
+        </p:nvSpPr>
+        <p:spPr>
+          <a:xfrm>
+            <a:off x="0" y="0"/>
+            <a:ext cx="12191695" cy="960120"/>
+          </a:xfrm>
+          <a:prstGeom prst="rect">
+            <a:avLst/>
+          </a:prstGeom>
+          <a:solidFill>
+            <a:srgbClr val="0D1321"/>
+          </a:solidFill>
+          <a:ln/>
+        </p:spPr>
+      </p:sp>
+      <p:sp>
+        <p:nvSpPr>
+          <p:cNvPr id="3" name="Shape 1"/>
+          <p:cNvSpPr/>
+          <p:nvPr/>
+        </p:nvSpPr>
+        <p:spPr>
+          <a:xfrm>
+            <a:off x="0" y="960120"/>
+            <a:ext cx="12191695" cy="41148"/>
+          </a:xfrm>
+          <a:prstGeom prst="rect">
+            <a:avLst/>
+          </a:prstGeom>
+          <a:solidFill>
+            <a:srgbClr val="6849F6"/>
+          </a:solidFill>
+          <a:ln/>
+        </p:spPr>
+      </p:sp>
+      <p:sp>
+        <p:nvSpPr>
+          <p:cNvPr id="4" name="Text 2"/>
+          <p:cNvSpPr/>
+          <p:nvPr/>
+        </p:nvSpPr>
+        <p:spPr>
+          <a:xfrm>
+            <a:off x="502920" y="256032"/>
+            <a:ext cx="3657600" cy="457200"/>
+          </a:xfrm>
+          <a:prstGeom prst="rect">
+            <a:avLst/>
+          </a:prstGeom>
+          <a:noFill/>
+          <a:ln/>
+        </p:spPr>
+        <p:txBody>
+          <a:bodyPr wrap="square" lIns="0" tIns="0" rIns="0" bIns="0" rtlCol="0" anchor="ctr"/>
+          <a:lstStyle/>
+          <a:p>
+            <a:pPr indent="0" marL="0">
+              <a:buNone/>
+            </a:pPr>
+            <a:r>
+              <a:rPr lang="en-US" sz="2000" b="1" dirty="0">
+                <a:solidFill>
+                  <a:srgbClr val="FFFFFF"/>
+                </a:solidFill>
+                <a:latin typeface="Helvetica" pitchFamily="34" charset="0"/>
+                <a:ea typeface="Helvetica" pitchFamily="34" charset="-122"/>
+                <a:cs typeface="Helvetica" pitchFamily="34" charset="-120"/>
+              </a:rPr>
+              <a:t>belajar</a:t>
+            </a:r>
+            <a:pPr indent="0" marL="0">
+              <a:buNone/>
+            </a:pPr>
+            <a:r>
+              <a:rPr lang="en-US" sz="2000" b="1" dirty="0">
+                <a:solidFill>
+                  <a:srgbClr val="8B7CF6"/>
+                </a:solidFill>
+                <a:latin typeface="Helvetica" pitchFamily="34" charset="0"/>
+                <a:ea typeface="Helvetica" pitchFamily="34" charset="-122"/>
+                <a:cs typeface="Helvetica" pitchFamily="34" charset="-120"/>
+              </a:rPr>
+              <a:t>claude</a:t>
+            </a:r>
+            <a:endParaRPr lang="en-US" sz="2000" dirty="0"/>
+          </a:p>
+        </p:txBody>
+      </p:sp>
+      <p:sp>
+        <p:nvSpPr>
+          <p:cNvPr id="5" name="Text 3"/>
+          <p:cNvSpPr/>
+          <p:nvPr/>
+        </p:nvSpPr>
+        <p:spPr>
+          <a:xfrm>
+            <a:off x="5943600" y="274320"/>
+            <a:ext cx="5760720" cy="411480"/>
+          </a:xfrm>
+          <a:prstGeom prst="rect">
+            <a:avLst/>
+          </a:prstGeom>
+          <a:noFill/>
+          <a:ln/>
+        </p:spPr>
+        <p:txBody>
+          <a:bodyPr wrap="square" lIns="0" tIns="0" rIns="0" bIns="0" rtlCol="0" anchor="ctr"/>
+          <a:lstStyle/>
+          <a:p>
+            <a:pPr algn="r" indent="0" marL="0">
+              <a:buNone/>
+            </a:pPr>
+            <a:r>
+              <a:rPr lang="en-US" sz="1250" dirty="0">
+                <a:solidFill>
+                  <a:srgbClr val="9AA2B4"/>
+                </a:solidFill>
+                <a:latin typeface="Helvetica" pitchFamily="34" charset="0"/>
+                <a:ea typeface="Helvetica" pitchFamily="34" charset="-122"/>
+                <a:cs typeface="Helvetica" pitchFamily="34" charset="-120"/>
+              </a:rPr>
+              <a:t>Modul 07 — Dokumen &amp; Riset</a:t>
+            </a:r>
+            <a:endParaRPr lang="en-US" sz="1250" dirty="0"/>
+          </a:p>
+        </p:txBody>
+      </p:sp>
+      <p:sp>
+        <p:nvSpPr>
+          <p:cNvPr id="6" name="Text 4"/>
+          <p:cNvSpPr/>
+          <p:nvPr/>
+        </p:nvSpPr>
+        <p:spPr>
+          <a:xfrm>
+            <a:off x="548640" y="1188720"/>
+            <a:ext cx="11064240" cy="502920"/>
+          </a:xfrm>
+          <a:prstGeom prst="rect">
+            <a:avLst/>
+          </a:prstGeom>
+          <a:noFill/>
+          <a:ln/>
+        </p:spPr>
+        <p:txBody>
+          <a:bodyPr wrap="square" lIns="0" tIns="0" rIns="0" bIns="0" rtlCol="0" anchor="ctr"/>
+          <a:lstStyle/>
+          <a:p>
+            <a:pPr indent="0" marL="0">
+              <a:buNone/>
+            </a:pPr>
+            <a:r>
+              <a:rPr lang="en-US" sz="2200" b="1" dirty="0">
+                <a:solidFill>
+                  <a:srgbClr val="0D1321"/>
+                </a:solidFill>
+                <a:latin typeface="Helvetica" pitchFamily="34" charset="0"/>
+                <a:ea typeface="Helvetica" pitchFamily="34" charset="-122"/>
+                <a:cs typeface="Helvetica" pitchFamily="34" charset="-120"/>
+              </a:rPr>
+              <a:t>Latihan &amp; Output</a:t>
+            </a:r>
+            <a:endParaRPr lang="en-US" sz="2200" dirty="0"/>
+          </a:p>
+        </p:txBody>
+      </p:sp>
+      <p:sp>
+        <p:nvSpPr>
+          <p:cNvPr id="7" name="Text 5"/>
+          <p:cNvSpPr/>
+          <p:nvPr/>
+        </p:nvSpPr>
+        <p:spPr>
+          <a:xfrm>
+            <a:off x="548640" y="1783080"/>
+            <a:ext cx="11094415" cy="274320"/>
+          </a:xfrm>
+          <a:prstGeom prst="rect">
+            <a:avLst/>
+          </a:prstGeom>
+          <a:noFill/>
+          <a:ln/>
+        </p:spPr>
+        <p:txBody>
+          <a:bodyPr wrap="square" lIns="0" tIns="0" rIns="0" bIns="0" rtlCol="0" anchor="ctr"/>
+          <a:lstStyle/>
+          <a:p>
+            <a:pPr indent="0" marL="0">
+              <a:buNone/>
+            </a:pPr>
+            <a:r>
+              <a:rPr lang="en-US" sz="1250" b="1" spc="40" kern="0" dirty="0">
+                <a:solidFill>
+                  <a:srgbClr val="4B36C7"/>
+                </a:solidFill>
+                <a:latin typeface="Helvetica" pitchFamily="34" charset="0"/>
+                <a:ea typeface="Helvetica" pitchFamily="34" charset="-122"/>
+                <a:cs typeface="Helvetica" pitchFamily="34" charset="-120"/>
+              </a:rPr>
+              <a:t>PRAKTIKKAN KEEMPAT SKILL DI KERJAANMU SENDIRI</a:t>
+            </a:r>
+            <a:endParaRPr lang="en-US" sz="1250" dirty="0"/>
+          </a:p>
+        </p:txBody>
+      </p:sp>
+      <p:sp>
+        <p:nvSpPr>
+          <p:cNvPr id="8" name="Shape 6"/>
+          <p:cNvSpPr/>
+          <p:nvPr/>
+        </p:nvSpPr>
+        <p:spPr>
+          <a:xfrm>
+            <a:off x="548640" y="2112264"/>
+            <a:ext cx="11094415" cy="1480376"/>
+          </a:xfrm>
+          <a:prstGeom prst="roundRect">
+            <a:avLst>
+              <a:gd name="adj" fmla="val 6177"/>
+            </a:avLst>
+          </a:prstGeom>
+          <a:solidFill>
+            <a:srgbClr val="EAFAF0"/>
+          </a:solidFill>
+          <a:ln w="12700">
+            <a:solidFill>
+              <a:srgbClr val="B8E6C9"/>
+            </a:solidFill>
+            <a:prstDash val="solid"/>
+          </a:ln>
+        </p:spPr>
+      </p:sp>
+      <p:sp>
+        <p:nvSpPr>
+          <p:cNvPr id="9" name="Text 7"/>
+          <p:cNvSpPr/>
+          <p:nvPr/>
+        </p:nvSpPr>
+        <p:spPr>
+          <a:xfrm>
+            <a:off x="749808" y="2313432"/>
+            <a:ext cx="10692079" cy="274320"/>
+          </a:xfrm>
+          <a:prstGeom prst="rect">
+            <a:avLst/>
+          </a:prstGeom>
+          <a:noFill/>
+          <a:ln/>
+        </p:spPr>
+        <p:txBody>
+          <a:bodyPr wrap="square" lIns="0" tIns="0" rIns="0" bIns="0" rtlCol="0" anchor="ctr"/>
+          <a:lstStyle/>
+          <a:p>
+            <a:pPr indent="0" marL="0">
+              <a:buNone/>
+            </a:pPr>
+            <a:r>
+              <a:rPr lang="en-US" sz="1250" b="1" spc="30" kern="0" dirty="0">
+                <a:solidFill>
+                  <a:srgbClr val="1A7A44"/>
+                </a:solidFill>
+                <a:latin typeface="Helvetica" pitchFamily="34" charset="0"/>
+                <a:ea typeface="Helvetica" pitchFamily="34" charset="-122"/>
+                <a:cs typeface="Helvetica" pitchFamily="34" charset="-120"/>
+              </a:rPr>
+              <a:t>■  LATIHAN</a:t>
+            </a:r>
+            <a:endParaRPr lang="en-US" sz="1250" dirty="0"/>
+          </a:p>
+        </p:txBody>
+      </p:sp>
+      <p:sp>
+        <p:nvSpPr>
+          <p:cNvPr id="10" name="Text 8"/>
+          <p:cNvSpPr/>
+          <p:nvPr/>
+        </p:nvSpPr>
+        <p:spPr>
+          <a:xfrm>
+            <a:off x="749808" y="2660904"/>
+            <a:ext cx="10692079" cy="730568"/>
+          </a:xfrm>
+          <a:prstGeom prst="rect">
+            <a:avLst/>
+          </a:prstGeom>
+          <a:noFill/>
+          <a:ln/>
+        </p:spPr>
+        <p:txBody>
+          <a:bodyPr wrap="square" lIns="0" tIns="0" rIns="0" bIns="0" rtlCol="0" anchor="t"/>
+          <a:lstStyle/>
+          <a:p>
+            <a:pPr indent="0" marL="0">
+              <a:lnSpc>
+                <a:spcPct val="130000"/>
+              </a:lnSpc>
+              <a:buNone/>
+            </a:pPr>
+            <a:r>
+              <a:rPr lang="en-US" sz="1250" dirty="0">
+                <a:solidFill>
+                  <a:srgbClr val="23283A"/>
+                </a:solidFill>
+                <a:latin typeface="Helvetica" pitchFamily="34" charset="0"/>
+                <a:ea typeface="Helvetica" pitchFamily="34" charset="-122"/>
+                <a:cs typeface="Helvetica" pitchFamily="34" charset="-120"/>
+              </a:rPr>
+              <a:t>Ambil 1 catatan rapat terakhir → minta action items. Pilih 1 dokumen yang "menunggu" dibaca → minta ringkasan sesuai keputusan yang perlu kamu buat. Jelaskan 1 keputusan bisnis yang dipertimbangkan → minta SWOT, lalu ubah jadi slide presentasi. Ceritakan 1 proses kerja → minta SOP.</a:t>
+            </a:r>
+            <a:endParaRPr lang="en-US" sz="1250" dirty="0"/>
+          </a:p>
+        </p:txBody>
+      </p:sp>
+      <p:sp>
+        <p:nvSpPr>
+          <p:cNvPr id="11" name="Shape 9"/>
+          <p:cNvSpPr/>
+          <p:nvPr/>
+        </p:nvSpPr>
+        <p:spPr>
+          <a:xfrm>
+            <a:off x="548640" y="3830384"/>
+            <a:ext cx="11094415" cy="993331"/>
+          </a:xfrm>
+          <a:prstGeom prst="roundRect">
+            <a:avLst>
+              <a:gd name="adj" fmla="val 9205"/>
+            </a:avLst>
+          </a:prstGeom>
+          <a:solidFill>
+            <a:srgbClr val="EAFAF0"/>
+          </a:solidFill>
+          <a:ln w="12700">
+            <a:solidFill>
+              <a:srgbClr val="B8E6C9"/>
+            </a:solidFill>
+            <a:prstDash val="solid"/>
+          </a:ln>
+        </p:spPr>
+      </p:sp>
+      <p:sp>
+        <p:nvSpPr>
+          <p:cNvPr id="12" name="Text 10"/>
+          <p:cNvSpPr/>
+          <p:nvPr/>
+        </p:nvSpPr>
+        <p:spPr>
+          <a:xfrm>
+            <a:off x="749808" y="4031552"/>
+            <a:ext cx="10692079" cy="274320"/>
+          </a:xfrm>
+          <a:prstGeom prst="rect">
+            <a:avLst/>
+          </a:prstGeom>
+          <a:noFill/>
+          <a:ln/>
+        </p:spPr>
+        <p:txBody>
+          <a:bodyPr wrap="square" lIns="0" tIns="0" rIns="0" bIns="0" rtlCol="0" anchor="ctr"/>
+          <a:lstStyle/>
+          <a:p>
+            <a:pPr indent="0" marL="0">
+              <a:buNone/>
+            </a:pPr>
+            <a:r>
+              <a:rPr lang="en-US" sz="1250" b="1" spc="30" kern="0" dirty="0">
+                <a:solidFill>
+                  <a:srgbClr val="1A7A44"/>
+                </a:solidFill>
+                <a:latin typeface="Helvetica" pitchFamily="34" charset="0"/>
+                <a:ea typeface="Helvetica" pitchFamily="34" charset="-122"/>
+                <a:cs typeface="Helvetica" pitchFamily="34" charset="-120"/>
+              </a:rPr>
+              <a:t>■  OUTPUT</a:t>
+            </a:r>
+            <a:endParaRPr lang="en-US" sz="1250" dirty="0"/>
+          </a:p>
+        </p:txBody>
+      </p:sp>
+      <p:sp>
+        <p:nvSpPr>
+          <p:cNvPr id="13" name="Text 11"/>
+          <p:cNvSpPr/>
+          <p:nvPr/>
+        </p:nvSpPr>
+        <p:spPr>
+          <a:xfrm>
+            <a:off x="749808" y="4379024"/>
+            <a:ext cx="10692079" cy="243523"/>
+          </a:xfrm>
+          <a:prstGeom prst="rect">
+            <a:avLst/>
+          </a:prstGeom>
+          <a:noFill/>
+          <a:ln/>
+        </p:spPr>
+        <p:txBody>
+          <a:bodyPr wrap="square" lIns="0" tIns="0" rIns="0" bIns="0" rtlCol="0" anchor="t"/>
+          <a:lstStyle/>
+          <a:p>
+            <a:pPr indent="0" marL="0">
+              <a:lnSpc>
+                <a:spcPct val="130000"/>
+              </a:lnSpc>
+              <a:buNone/>
+            </a:pPr>
+            <a:r>
+              <a:rPr lang="en-US" sz="1250" dirty="0">
+                <a:solidFill>
+                  <a:srgbClr val="23283A"/>
+                </a:solidFill>
+                <a:latin typeface="Helvetica" pitchFamily="34" charset="0"/>
+                <a:ea typeface="Helvetica" pitchFamily="34" charset="-122"/>
+                <a:cs typeface="Helvetica" pitchFamily="34" charset="-120"/>
+              </a:rPr>
+              <a:t>4 output siap pakai: tabel action items, ringkasan dokumen, SWOT 1 halaman, dan 1 SOP untuk pegawai baru.</a:t>
+            </a:r>
+            <a:endParaRPr lang="en-US" sz="1250" dirty="0"/>
+          </a:p>
+        </p:txBody>
+      </p:sp>
+    </p:spTree>
+  </p:cSld>
+  <p:clrMapOvr>
+    <a:masterClrMapping/>
+  </p:clrMapOvr>
+</p:sld>
+</file>
+
+<file path=ppt/slides/slide9.xml><?xml version="1.0" encoding="utf-8"?>
+<p:sld xmlns:a="http://schemas.openxmlformats.org/drawingml/2006/main" xmlns:r="http://schemas.openxmlformats.org/officeDocument/2006/relationships" xmlns:p="http://schemas.openxmlformats.org/presentationml/2006/main">
+  <p:cSld name="Slide 9">
     <p:bg>
       <p:bgPr>
         <a:solidFill>

</xml_diff>

<commit_message>
Checkpoint 30: verify Pro-plan claims, sync PDF content, design audit, adopt local M7 PPTX
</commit_message>
<xml_diff>
--- a/K2-Produktivitas/M07-Dokumen-Riset/K2-M07-Dokumen-Riset.pptx
+++ b/K2-Produktivitas/M07-Dokumen-Riset/K2-M07-Dokumen-Riset.pptx
@@ -4,6 +4,9 @@
   <p:sldMasterIdLst>
     <p:sldMasterId id="2147483648" r:id="rId1"/>
   </p:sldMasterIdLst>
+  <p:notesMasterIdLst>
+    <p:notesMasterId r:id="rId11"/>
+  </p:notesMasterIdLst>
   <p:sldIdLst>
     <p:sldId id="256" r:id="rId2"/>
     <p:sldId id="257" r:id="rId3"/>
@@ -15,11 +18,8 @@
     <p:sldId id="263" r:id="rId9"/>
     <p:sldId id="264" r:id="rId10"/>
   </p:sldIdLst>
-  <p:notesMasterIdLst>
-    <p:notesMasterId r:id="rId11"/>
-  </p:notesMasterIdLst>
-  <p:sldSz cx="12191695" cy="6858000"/>
-  <p:notesSz cx="6858000" cy="12191695"/>
+  <p:sldSz cx="12192000" cy="6858000"/>
+  <p:notesSz cx="6858000" cy="12192000"/>
   <p:defaultTextStyle>
     <a:lvl1pPr marL="0" algn="l" defTabSz="914400" rtl="0" eaLnBrk="1" latinLnBrk="0" hangingPunct="1">
       <a:defRPr sz="1800" kern="1200">
@@ -112,6 +112,11 @@
       </a:defRPr>
     </a:lvl9pPr>
   </p:defaultTextStyle>
+  <p:extLst>
+    <p:ext uri="{EFAFB233-063F-42B5-8137-9DF3F51BA10A}">
+      <p15:sldGuideLst xmlns:p15="http://schemas.microsoft.com/office/powerpoint/2012/main"/>
+    </p:ext>
+  </p:extLst>
 </p:presentation>
 </file>
 
@@ -137,234 +142,10 @@
           <a:chExt cx="0" cy="0"/>
         </a:xfrm>
       </p:grpSpPr>
-      <p:sp>
-        <p:nvSpPr>
-          <p:cNvPr id="2" name="Header Placeholder 1"/>
-          <p:cNvSpPr>
-            <a:spLocks noGrp="1"/>
-          </p:cNvSpPr>
-          <p:nvPr>
-            <p:ph type="hdr" sz="quarter"/>
-          </p:nvPr>
-        </p:nvSpPr>
-        <p:spPr>
-          <a:xfrm>
-            <a:off x="0" y="0"/>
-            <a:ext cx="2971800" cy="458788"/>
-          </a:xfrm>
-          <a:prstGeom prst="rect">
-            <a:avLst/>
-          </a:prstGeom>
-        </p:spPr>
-        <p:txBody>
-          <a:bodyPr vert="horz" lIns="91440" tIns="45720" rIns="91440" bIns="45720" rtlCol="0"/>
-          <a:lstStyle>
-            <a:lvl1pPr algn="l">
-              <a:defRPr sz="1200"/>
-            </a:lvl1pPr>
-          </a:lstStyle>
-          <a:p>
-            <a:endParaRPr lang="en-US"/>
-          </a:p>
-        </p:txBody>
-      </p:sp>
-      <p:sp>
-        <p:nvSpPr>
-          <p:cNvPr id="3" name="Date Placeholder 2"/>
-          <p:cNvSpPr>
-            <a:spLocks noGrp="1"/>
-          </p:cNvSpPr>
-          <p:nvPr>
-            <p:ph type="dt" idx="1"/>
-          </p:nvPr>
-        </p:nvSpPr>
-        <p:spPr>
-          <a:xfrm>
-            <a:off x="3884613" y="0"/>
-            <a:ext cx="2971800" cy="458788"/>
-          </a:xfrm>
-          <a:prstGeom prst="rect">
-            <a:avLst/>
-          </a:prstGeom>
-        </p:spPr>
-        <p:txBody>
-          <a:bodyPr vert="horz" lIns="91440" tIns="45720" rIns="91440" bIns="45720" rtlCol="0"/>
-          <a:lstStyle>
-            <a:lvl1pPr algn="r">
-              <a:defRPr sz="1200"/>
-            </a:lvl1pPr>
-          </a:lstStyle>
-          <a:p>
-            <a:fld id="{5282F153-3F37-0F45-9E97-73ACFA13230C}" type="datetimeFigureOut">
-              <a:rPr lang="en-US"/>
-              <a:t>7/23/19</a:t>
-            </a:fld>
-            <a:endParaRPr lang="en-US"/>
-          </a:p>
-        </p:txBody>
-      </p:sp>
-      <p:sp>
-        <p:nvSpPr>
-          <p:cNvPr id="4" name="Slide Image Placeholder 3"/>
-          <p:cNvSpPr>
-            <a:spLocks noGrp="1" noRot="1" noChangeAspect="1"/>
-          </p:cNvSpPr>
-          <p:nvPr>
-            <p:ph type="sldImg" idx="2"/>
-          </p:nvPr>
-        </p:nvSpPr>
-        <p:spPr>
-          <a:xfrm>
-            <a:off x="685800" y="1143000"/>
-            <a:ext cx="5486400" cy="3086100"/>
-          </a:xfrm>
-          <a:prstGeom prst="rect">
-            <a:avLst/>
-          </a:prstGeom>
-          <a:noFill/>
-          <a:ln w="12700">
-            <a:solidFill>
-              <a:prstClr val="black"/>
-            </a:solidFill>
-          </a:ln>
-        </p:spPr>
-        <p:txBody>
-          <a:bodyPr vert="horz" lIns="91440" tIns="45720" rIns="91440" bIns="45720" rtlCol="0" anchor="ctr"/>
-          <a:lstStyle/>
-          <a:p>
-            <a:endParaRPr lang="en-US"/>
-          </a:p>
-        </p:txBody>
-      </p:sp>
-      <p:sp>
-        <p:nvSpPr>
-          <p:cNvPr id="5" name="Notes Placeholder 4"/>
-          <p:cNvSpPr>
-            <a:spLocks noGrp="1"/>
-          </p:cNvSpPr>
-          <p:nvPr>
-            <p:ph type="body" sz="quarter" idx="3"/>
-          </p:nvPr>
-        </p:nvSpPr>
-        <p:spPr>
-          <a:xfrm>
-            <a:off x="685800" y="4400550"/>
-            <a:ext cx="5486400" cy="3600450"/>
-          </a:xfrm>
-          <a:prstGeom prst="rect">
-            <a:avLst/>
-          </a:prstGeom>
-        </p:spPr>
-        <p:txBody>
-          <a:bodyPr vert="horz" lIns="91440" tIns="45720" rIns="91440" bIns="45720" rtlCol="0"/>
-          <a:lstStyle/>
-          <a:p>
-            <a:pPr lvl="0"/>
-            <a:r>
-              <a:rPr lang="en-US"/>
-              <a:t>Click to edit Master text styles</a:t>
-            </a:r>
-          </a:p>
-          <a:p>
-            <a:pPr lvl="1"/>
-            <a:r>
-              <a:rPr lang="en-US"/>
-              <a:t>Second level</a:t>
-            </a:r>
-          </a:p>
-          <a:p>
-            <a:pPr lvl="2"/>
-            <a:r>
-              <a:rPr lang="en-US"/>
-              <a:t>Third level</a:t>
-            </a:r>
-          </a:p>
-          <a:p>
-            <a:pPr lvl="3"/>
-            <a:r>
-              <a:rPr lang="en-US"/>
-              <a:t>Fourth level</a:t>
-            </a:r>
-          </a:p>
-          <a:p>
-            <a:pPr lvl="4"/>
-            <a:r>
-              <a:rPr lang="en-US"/>
-              <a:t>Fifth level</a:t>
-            </a:r>
-          </a:p>
-        </p:txBody>
-      </p:sp>
-      <p:sp>
-        <p:nvSpPr>
-          <p:cNvPr id="6" name="Footer Placeholder 5"/>
-          <p:cNvSpPr>
-            <a:spLocks noGrp="1"/>
-          </p:cNvSpPr>
-          <p:nvPr>
-            <p:ph type="ftr" sz="quarter" idx="4"/>
-          </p:nvPr>
-        </p:nvSpPr>
-        <p:spPr>
-          <a:xfrm>
-            <a:off x="0" y="8685213"/>
-            <a:ext cx="2971800" cy="458787"/>
-          </a:xfrm>
-          <a:prstGeom prst="rect">
-            <a:avLst/>
-          </a:prstGeom>
-        </p:spPr>
-        <p:txBody>
-          <a:bodyPr vert="horz" lIns="91440" tIns="45720" rIns="91440" bIns="45720" rtlCol="0" anchor="b"/>
-          <a:lstStyle>
-            <a:lvl1pPr algn="l">
-              <a:defRPr sz="1200"/>
-            </a:lvl1pPr>
-          </a:lstStyle>
-          <a:p>
-            <a:endParaRPr lang="en-US"/>
-          </a:p>
-        </p:txBody>
-      </p:sp>
-      <p:sp>
-        <p:nvSpPr>
-          <p:cNvPr id="7" name="Slide Number Placeholder 6"/>
-          <p:cNvSpPr>
-            <a:spLocks noGrp="1"/>
-          </p:cNvSpPr>
-          <p:nvPr>
-            <p:ph type="sldNum" sz="quarter" idx="5"/>
-          </p:nvPr>
-        </p:nvSpPr>
-        <p:spPr>
-          <a:xfrm>
-            <a:off x="3884613" y="8685213"/>
-            <a:ext cx="2971800" cy="458787"/>
-          </a:xfrm>
-          <a:prstGeom prst="rect">
-            <a:avLst/>
-          </a:prstGeom>
-        </p:spPr>
-        <p:txBody>
-          <a:bodyPr vert="horz" lIns="91440" tIns="45720" rIns="91440" bIns="45720" rtlCol="0" anchor="b"/>
-          <a:lstStyle>
-            <a:lvl1pPr algn="r">
-              <a:defRPr sz="1200"/>
-            </a:lvl1pPr>
-          </a:lstStyle>
-          <a:p>
-            <a:fld id="{CE5E9CC1-C706-0F49-92D6-E571CC5EEA8F}" type="slidenum">
-              <a:rPr lang="en-US"/>
-              <a:t>‹#›</a:t>
-            </a:fld>
-            <a:endParaRPr lang="en-US"/>
-          </a:p>
-        </p:txBody>
-      </p:sp>
     </p:spTree>
     <p:extLst>
       <p:ext uri="{BB962C8B-B14F-4D97-AF65-F5344CB8AC3E}">
-        <p14:creationId xmlns:p14="http://schemas.microsoft.com/office/powerpoint/2010/main" val="1024086991"/>
+        <p14:creationId xmlns:p14="http://schemas.microsoft.com/office/powerpoint/2010/main" val="2500133314"/>
       </p:ext>
     </p:extLst>
   </p:cSld>
@@ -508,10 +289,6 @@
           <a:bodyPr/>
           <a:lstStyle/>
           <a:p>
-            <a:r>
-              <a:rPr lang="en-US" dirty="0"/>
-              <a:t/>
-            </a:r>
             <a:endParaRPr lang="en-US" dirty="0"/>
           </a:p>
         </p:txBody>
@@ -596,10 +373,6 @@
           <a:bodyPr/>
           <a:lstStyle/>
           <a:p>
-            <a:r>
-              <a:rPr lang="en-US" dirty="0"/>
-              <a:t/>
-            </a:r>
             <a:endParaRPr lang="en-US" dirty="0"/>
           </a:p>
         </p:txBody>
@@ -684,10 +457,6 @@
           <a:bodyPr/>
           <a:lstStyle/>
           <a:p>
-            <a:r>
-              <a:rPr lang="en-US" dirty="0"/>
-              <a:t/>
-            </a:r>
             <a:endParaRPr lang="en-US" dirty="0"/>
           </a:p>
         </p:txBody>
@@ -772,10 +541,6 @@
           <a:bodyPr/>
           <a:lstStyle/>
           <a:p>
-            <a:r>
-              <a:rPr lang="en-US" dirty="0"/>
-              <a:t/>
-            </a:r>
             <a:endParaRPr lang="en-US" dirty="0"/>
           </a:p>
         </p:txBody>
@@ -860,10 +625,6 @@
           <a:bodyPr/>
           <a:lstStyle/>
           <a:p>
-            <a:r>
-              <a:rPr lang="en-US" dirty="0"/>
-              <a:t/>
-            </a:r>
             <a:endParaRPr lang="en-US" dirty="0"/>
           </a:p>
         </p:txBody>
@@ -948,10 +709,6 @@
           <a:bodyPr/>
           <a:lstStyle/>
           <a:p>
-            <a:r>
-              <a:rPr lang="en-US" dirty="0"/>
-              <a:t/>
-            </a:r>
             <a:endParaRPr lang="en-US" dirty="0"/>
           </a:p>
         </p:txBody>
@@ -1036,10 +793,6 @@
           <a:bodyPr/>
           <a:lstStyle/>
           <a:p>
-            <a:r>
-              <a:rPr lang="en-US" dirty="0"/>
-              <a:t/>
-            </a:r>
             <a:endParaRPr lang="en-US" dirty="0"/>
           </a:p>
         </p:txBody>
@@ -1124,10 +877,6 @@
           <a:bodyPr/>
           <a:lstStyle/>
           <a:p>
-            <a:r>
-              <a:rPr lang="en-US" dirty="0"/>
-              <a:t/>
-            </a:r>
             <a:endParaRPr lang="en-US" dirty="0"/>
           </a:p>
         </p:txBody>
@@ -1212,10 +961,6 @@
           <a:bodyPr/>
           <a:lstStyle/>
           <a:p>
-            <a:r>
-              <a:rPr lang="en-US" dirty="0"/>
-              <a:t/>
-            </a:r>
             <a:endParaRPr lang="en-US" dirty="0"/>
           </a:p>
         </p:txBody>
@@ -1289,6 +1034,11 @@
 <file path=ppt/slideMasters/slideMaster1.xml><?xml version="1.0" encoding="utf-8"?>
 <p:sldMaster xmlns:a="http://schemas.openxmlformats.org/drawingml/2006/main" xmlns:r="http://schemas.openxmlformats.org/officeDocument/2006/relationships" xmlns:p="http://schemas.openxmlformats.org/presentationml/2006/main">
   <p:cSld>
+    <p:bg>
+      <p:bgRef idx="1001">
+        <a:schemeClr val="bg1"/>
+      </p:bgRef>
+    </p:bg>
     <p:spTree>
       <p:nvGrpSpPr>
         <p:cNvPr id="1" name=""/>
@@ -1571,6 +1321,7 @@
         <a:solidFill>
           <a:srgbClr val="0D1321"/>
         </a:solidFill>
+        <a:effectLst/>
       </p:bgPr>
     </p:bg>
     <p:spTree>
@@ -1606,6 +1357,13 @@
           </a:solidFill>
           <a:ln/>
         </p:spPr>
+        <p:txBody>
+          <a:bodyPr/>
+          <a:lstStyle/>
+          <a:p>
+            <a:endParaRPr lang="en-ID"/>
+          </a:p>
+        </p:txBody>
       </p:sp>
       <p:sp>
         <p:nvSpPr>
@@ -1628,7 +1386,7 @@
           <a:bodyPr wrap="square" lIns="0" tIns="0" rIns="0" bIns="0" rtlCol="0" anchor="ctr"/>
           <a:lstStyle/>
           <a:p>
-            <a:pPr indent="0" marL="0">
+            <a:pPr marL="0" indent="0">
               <a:buNone/>
             </a:pPr>
             <a:r>
@@ -1642,9 +1400,6 @@
               </a:rPr>
               <a:t>belajar</a:t>
             </a:r>
-            <a:pPr indent="0" marL="0">
-              <a:buNone/>
-            </a:pPr>
             <a:r>
               <a:rPr lang="en-US" sz="2000" b="1" dirty="0">
                 <a:solidFill>
@@ -1681,6 +1436,13 @@
           </a:solidFill>
           <a:ln/>
         </p:spPr>
+        <p:txBody>
+          <a:bodyPr/>
+          <a:lstStyle/>
+          <a:p>
+            <a:endParaRPr lang="en-ID"/>
+          </a:p>
+        </p:txBody>
       </p:sp>
       <p:sp>
         <p:nvSpPr>
@@ -1703,7 +1465,7 @@
           <a:bodyPr wrap="square" lIns="0" tIns="0" rIns="0" bIns="0" rtlCol="0" anchor="ctr"/>
           <a:lstStyle/>
           <a:p>
-            <a:pPr algn="ctr" indent="0" marL="0">
+            <a:pPr marL="0" indent="0" algn="ctr">
               <a:buNone/>
             </a:pPr>
             <a:r>
@@ -1742,11 +1504,11 @@
           <a:bodyPr wrap="square" lIns="0" tIns="0" rIns="0" bIns="0" rtlCol="0" anchor="ctr"/>
           <a:lstStyle/>
           <a:p>
-            <a:pPr indent="0" marL="0">
-              <a:buNone/>
-            </a:pPr>
-            <a:r>
-              <a:rPr lang="en-US" sz="1300" b="1" spc="40" kern="0" dirty="0">
+            <a:pPr marL="0" indent="0">
+              <a:buNone/>
+            </a:pPr>
+            <a:r>
+              <a:rPr lang="en-US" sz="1300" b="1" kern="0" spc="40" dirty="0">
                 <a:solidFill>
                   <a:srgbClr val="8B7CF6"/>
                 </a:solidFill>
@@ -1781,7 +1543,7 @@
           <a:bodyPr wrap="square" lIns="0" tIns="0" rIns="0" bIns="0" rtlCol="0" anchor="t"/>
           <a:lstStyle/>
           <a:p>
-            <a:pPr indent="0" marL="0">
+            <a:pPr marL="0" indent="0">
               <a:lnSpc>
                 <a:spcPts val="5000"/>
               </a:lnSpc>
@@ -1823,7 +1585,7 @@
           <a:bodyPr wrap="square" lIns="0" tIns="0" rIns="0" bIns="0" rtlCol="0" anchor="t"/>
           <a:lstStyle/>
           <a:p>
-            <a:pPr indent="0" marL="0">
+            <a:pPr marL="0" indent="0">
               <a:lnSpc>
                 <a:spcPct val="130000"/>
               </a:lnSpc>
@@ -1860,6 +1622,7 @@
         <a:solidFill>
           <a:srgbClr val="FFFFFF"/>
         </a:solidFill>
+        <a:effectLst/>
       </p:bgPr>
     </p:bg>
     <p:spTree>
@@ -1895,6 +1658,13 @@
           </a:solidFill>
           <a:ln/>
         </p:spPr>
+        <p:txBody>
+          <a:bodyPr/>
+          <a:lstStyle/>
+          <a:p>
+            <a:endParaRPr lang="en-ID"/>
+          </a:p>
+        </p:txBody>
       </p:sp>
       <p:sp>
         <p:nvSpPr>
@@ -1915,6 +1685,13 @@
           </a:solidFill>
           <a:ln/>
         </p:spPr>
+        <p:txBody>
+          <a:bodyPr/>
+          <a:lstStyle/>
+          <a:p>
+            <a:endParaRPr lang="en-ID"/>
+          </a:p>
+        </p:txBody>
       </p:sp>
       <p:sp>
         <p:nvSpPr>
@@ -1937,7 +1714,7 @@
           <a:bodyPr wrap="square" lIns="0" tIns="0" rIns="0" bIns="0" rtlCol="0" anchor="ctr"/>
           <a:lstStyle/>
           <a:p>
-            <a:pPr indent="0" marL="0">
+            <a:pPr marL="0" indent="0">
               <a:buNone/>
             </a:pPr>
             <a:r>
@@ -1951,9 +1728,6 @@
               </a:rPr>
               <a:t>belajar</a:t>
             </a:r>
-            <a:pPr indent="0" marL="0">
-              <a:buNone/>
-            </a:pPr>
             <a:r>
               <a:rPr lang="en-US" sz="2000" b="1" dirty="0">
                 <a:solidFill>
@@ -1990,7 +1764,7 @@
           <a:bodyPr wrap="square" lIns="0" tIns="0" rIns="0" bIns="0" rtlCol="0" anchor="ctr"/>
           <a:lstStyle/>
           <a:p>
-            <a:pPr algn="r" indent="0" marL="0">
+            <a:pPr marL="0" indent="0" algn="r">
               <a:buNone/>
             </a:pPr>
             <a:r>
@@ -2029,7 +1803,7 @@
           <a:bodyPr wrap="square" lIns="0" tIns="0" rIns="0" bIns="0" rtlCol="0" anchor="ctr"/>
           <a:lstStyle/>
           <a:p>
-            <a:pPr indent="0" marL="0">
+            <a:pPr marL="0" indent="0">
               <a:buNone/>
             </a:pPr>
             <a:r>
@@ -2068,11 +1842,11 @@
           <a:bodyPr wrap="square" lIns="0" tIns="0" rIns="0" bIns="0" rtlCol="0" anchor="ctr"/>
           <a:lstStyle/>
           <a:p>
-            <a:pPr indent="0" marL="0">
-              <a:buNone/>
-            </a:pPr>
-            <a:r>
-              <a:rPr lang="en-US" sz="1250" b="1" spc="40" kern="0" dirty="0">
+            <a:pPr marL="0" indent="0">
+              <a:buNone/>
+            </a:pPr>
+            <a:r>
+              <a:rPr lang="en-US" sz="1250" b="1" kern="0" spc="40" dirty="0">
                 <a:solidFill>
                   <a:srgbClr val="4B36C7"/>
                 </a:solidFill>
@@ -2112,6 +1886,13 @@
             <a:prstDash val="solid"/>
           </a:ln>
         </p:spPr>
+        <p:txBody>
+          <a:bodyPr/>
+          <a:lstStyle/>
+          <a:p>
+            <a:endParaRPr lang="en-ID"/>
+          </a:p>
+        </p:txBody>
       </p:sp>
       <p:sp>
         <p:nvSpPr>
@@ -2132,6 +1913,13 @@
           </a:solidFill>
           <a:ln/>
         </p:spPr>
+        <p:txBody>
+          <a:bodyPr/>
+          <a:lstStyle/>
+          <a:p>
+            <a:endParaRPr lang="en-ID"/>
+          </a:p>
+        </p:txBody>
       </p:sp>
       <p:sp>
         <p:nvSpPr>
@@ -2154,7 +1942,7 @@
           <a:bodyPr wrap="square" lIns="0" tIns="0" rIns="0" bIns="0" rtlCol="0" anchor="ctr"/>
           <a:lstStyle/>
           <a:p>
-            <a:pPr algn="ctr" indent="0" marL="0">
+            <a:pPr marL="0" indent="0" algn="ctr">
               <a:buNone/>
             </a:pPr>
             <a:r>
@@ -2193,7 +1981,7 @@
           <a:bodyPr wrap="square" lIns="0" tIns="0" rIns="0" bIns="0" rtlCol="0" anchor="ctr"/>
           <a:lstStyle/>
           <a:p>
-            <a:pPr indent="0" marL="0">
+            <a:pPr marL="0" indent="0">
               <a:buNone/>
             </a:pPr>
             <a:r>
@@ -2232,7 +2020,7 @@
           <a:bodyPr wrap="square" lIns="0" tIns="0" rIns="0" bIns="0" rtlCol="0" anchor="t"/>
           <a:lstStyle/>
           <a:p>
-            <a:pPr indent="0" marL="0">
+            <a:pPr marL="0" indent="0">
               <a:lnSpc>
                 <a:spcPct val="122000"/>
               </a:lnSpc>
@@ -2279,6 +2067,13 @@
             <a:prstDash val="solid"/>
           </a:ln>
         </p:spPr>
+        <p:txBody>
+          <a:bodyPr/>
+          <a:lstStyle/>
+          <a:p>
+            <a:endParaRPr lang="en-ID"/>
+          </a:p>
+        </p:txBody>
       </p:sp>
       <p:sp>
         <p:nvSpPr>
@@ -2299,6 +2094,13 @@
           </a:solidFill>
           <a:ln/>
         </p:spPr>
+        <p:txBody>
+          <a:bodyPr/>
+          <a:lstStyle/>
+          <a:p>
+            <a:endParaRPr lang="en-ID"/>
+          </a:p>
+        </p:txBody>
       </p:sp>
       <p:sp>
         <p:nvSpPr>
@@ -2321,7 +2123,7 @@
           <a:bodyPr wrap="square" lIns="0" tIns="0" rIns="0" bIns="0" rtlCol="0" anchor="ctr"/>
           <a:lstStyle/>
           <a:p>
-            <a:pPr algn="ctr" indent="0" marL="0">
+            <a:pPr marL="0" indent="0" algn="ctr">
               <a:buNone/>
             </a:pPr>
             <a:r>
@@ -2360,7 +2162,7 @@
           <a:bodyPr wrap="square" lIns="0" tIns="0" rIns="0" bIns="0" rtlCol="0" anchor="ctr"/>
           <a:lstStyle/>
           <a:p>
-            <a:pPr indent="0" marL="0">
+            <a:pPr marL="0" indent="0">
               <a:buNone/>
             </a:pPr>
             <a:r>
@@ -2399,7 +2201,7 @@
           <a:bodyPr wrap="square" lIns="0" tIns="0" rIns="0" bIns="0" rtlCol="0" anchor="t"/>
           <a:lstStyle/>
           <a:p>
-            <a:pPr indent="0" marL="0">
+            <a:pPr marL="0" indent="0">
               <a:lnSpc>
                 <a:spcPct val="122000"/>
               </a:lnSpc>
@@ -2446,6 +2248,13 @@
             <a:prstDash val="solid"/>
           </a:ln>
         </p:spPr>
+        <p:txBody>
+          <a:bodyPr/>
+          <a:lstStyle/>
+          <a:p>
+            <a:endParaRPr lang="en-ID"/>
+          </a:p>
+        </p:txBody>
       </p:sp>
       <p:sp>
         <p:nvSpPr>
@@ -2466,6 +2275,13 @@
           </a:solidFill>
           <a:ln/>
         </p:spPr>
+        <p:txBody>
+          <a:bodyPr/>
+          <a:lstStyle/>
+          <a:p>
+            <a:endParaRPr lang="en-ID"/>
+          </a:p>
+        </p:txBody>
       </p:sp>
       <p:sp>
         <p:nvSpPr>
@@ -2488,7 +2304,7 @@
           <a:bodyPr wrap="square" lIns="0" tIns="0" rIns="0" bIns="0" rtlCol="0" anchor="ctr"/>
           <a:lstStyle/>
           <a:p>
-            <a:pPr algn="ctr" indent="0" marL="0">
+            <a:pPr marL="0" indent="0" algn="ctr">
               <a:buNone/>
             </a:pPr>
             <a:r>
@@ -2527,7 +2343,7 @@
           <a:bodyPr wrap="square" lIns="0" tIns="0" rIns="0" bIns="0" rtlCol="0" anchor="ctr"/>
           <a:lstStyle/>
           <a:p>
-            <a:pPr indent="0" marL="0">
+            <a:pPr marL="0" indent="0">
               <a:buNone/>
             </a:pPr>
             <a:r>
@@ -2566,7 +2382,7 @@
           <a:bodyPr wrap="square" lIns="0" tIns="0" rIns="0" bIns="0" rtlCol="0" anchor="t"/>
           <a:lstStyle/>
           <a:p>
-            <a:pPr indent="0" marL="0">
+            <a:pPr marL="0" indent="0">
               <a:lnSpc>
                 <a:spcPct val="122000"/>
               </a:lnSpc>
@@ -2613,6 +2429,13 @@
             <a:prstDash val="solid"/>
           </a:ln>
         </p:spPr>
+        <p:txBody>
+          <a:bodyPr/>
+          <a:lstStyle/>
+          <a:p>
+            <a:endParaRPr lang="en-ID"/>
+          </a:p>
+        </p:txBody>
       </p:sp>
       <p:sp>
         <p:nvSpPr>
@@ -2633,6 +2456,13 @@
           </a:solidFill>
           <a:ln/>
         </p:spPr>
+        <p:txBody>
+          <a:bodyPr/>
+          <a:lstStyle/>
+          <a:p>
+            <a:endParaRPr lang="en-ID"/>
+          </a:p>
+        </p:txBody>
       </p:sp>
       <p:sp>
         <p:nvSpPr>
@@ -2655,7 +2485,7 @@
           <a:bodyPr wrap="square" lIns="0" tIns="0" rIns="0" bIns="0" rtlCol="0" anchor="ctr"/>
           <a:lstStyle/>
           <a:p>
-            <a:pPr algn="ctr" indent="0" marL="0">
+            <a:pPr marL="0" indent="0" algn="ctr">
               <a:buNone/>
             </a:pPr>
             <a:r>
@@ -2694,7 +2524,7 @@
           <a:bodyPr wrap="square" lIns="0" tIns="0" rIns="0" bIns="0" rtlCol="0" anchor="ctr"/>
           <a:lstStyle/>
           <a:p>
-            <a:pPr indent="0" marL="0">
+            <a:pPr marL="0" indent="0">
               <a:buNone/>
             </a:pPr>
             <a:r>
@@ -2733,7 +2563,7 @@
           <a:bodyPr wrap="square" lIns="0" tIns="0" rIns="0" bIns="0" rtlCol="0" anchor="t"/>
           <a:lstStyle/>
           <a:p>
-            <a:pPr indent="0" marL="0">
+            <a:pPr marL="0" indent="0">
               <a:lnSpc>
                 <a:spcPct val="122000"/>
               </a:lnSpc>
@@ -2775,7 +2605,7 @@
           <a:bodyPr wrap="square" lIns="0" tIns="0" rIns="0" bIns="0" rtlCol="0" anchor="t"/>
           <a:lstStyle/>
           <a:p>
-            <a:pPr indent="0" marL="0">
+            <a:pPr marL="0" indent="0">
               <a:lnSpc>
                 <a:spcPct val="128000"/>
               </a:lnSpc>
@@ -2812,6 +2642,7 @@
         <a:solidFill>
           <a:srgbClr val="FFFFFF"/>
         </a:solidFill>
+        <a:effectLst/>
       </p:bgPr>
     </p:bg>
     <p:spTree>
@@ -2847,6 +2678,13 @@
           </a:solidFill>
           <a:ln/>
         </p:spPr>
+        <p:txBody>
+          <a:bodyPr/>
+          <a:lstStyle/>
+          <a:p>
+            <a:endParaRPr lang="en-ID"/>
+          </a:p>
+        </p:txBody>
       </p:sp>
       <p:sp>
         <p:nvSpPr>
@@ -2867,6 +2705,13 @@
           </a:solidFill>
           <a:ln/>
         </p:spPr>
+        <p:txBody>
+          <a:bodyPr/>
+          <a:lstStyle/>
+          <a:p>
+            <a:endParaRPr lang="en-ID"/>
+          </a:p>
+        </p:txBody>
       </p:sp>
       <p:sp>
         <p:nvSpPr>
@@ -2889,7 +2734,7 @@
           <a:bodyPr wrap="square" lIns="0" tIns="0" rIns="0" bIns="0" rtlCol="0" anchor="ctr"/>
           <a:lstStyle/>
           <a:p>
-            <a:pPr indent="0" marL="0">
+            <a:pPr marL="0" indent="0">
               <a:buNone/>
             </a:pPr>
             <a:r>
@@ -2903,9 +2748,6 @@
               </a:rPr>
               <a:t>belajar</a:t>
             </a:r>
-            <a:pPr indent="0" marL="0">
-              <a:buNone/>
-            </a:pPr>
             <a:r>
               <a:rPr lang="en-US" sz="2000" b="1" dirty="0">
                 <a:solidFill>
@@ -2942,7 +2784,7 @@
           <a:bodyPr wrap="square" lIns="0" tIns="0" rIns="0" bIns="0" rtlCol="0" anchor="ctr"/>
           <a:lstStyle/>
           <a:p>
-            <a:pPr algn="r" indent="0" marL="0">
+            <a:pPr marL="0" indent="0" algn="r">
               <a:buNone/>
             </a:pPr>
             <a:r>
@@ -2981,7 +2823,7 @@
           <a:bodyPr wrap="square" lIns="0" tIns="0" rIns="0" bIns="0" rtlCol="0" anchor="ctr"/>
           <a:lstStyle/>
           <a:p>
-            <a:pPr indent="0" marL="0">
+            <a:pPr marL="0" indent="0">
               <a:buNone/>
             </a:pPr>
             <a:r>
@@ -3020,11 +2862,11 @@
           <a:bodyPr wrap="square" lIns="0" tIns="0" rIns="0" bIns="0" rtlCol="0" anchor="ctr"/>
           <a:lstStyle/>
           <a:p>
-            <a:pPr indent="0" marL="0">
-              <a:buNone/>
-            </a:pPr>
-            <a:r>
-              <a:rPr lang="en-US" sz="1250" b="1" spc="40" kern="0" dirty="0">
+            <a:pPr marL="0" indent="0">
+              <a:buNone/>
+            </a:pPr>
+            <a:r>
+              <a:rPr lang="en-US" sz="1250" b="1" kern="0" spc="40" dirty="0">
                 <a:solidFill>
                   <a:srgbClr val="4B36C7"/>
                 </a:solidFill>
@@ -3059,7 +2901,7 @@
           <a:bodyPr wrap="square" lIns="0" tIns="0" rIns="0" bIns="0" rtlCol="0" anchor="t"/>
           <a:lstStyle/>
           <a:p>
-            <a:pPr indent="0" marL="0">
+            <a:pPr marL="0" indent="0">
               <a:lnSpc>
                 <a:spcPct val="128000"/>
               </a:lnSpc>
@@ -3106,6 +2948,13 @@
             <a:prstDash val="solid"/>
           </a:ln>
         </p:spPr>
+        <p:txBody>
+          <a:bodyPr/>
+          <a:lstStyle/>
+          <a:p>
+            <a:endParaRPr lang="en-ID"/>
+          </a:p>
+        </p:txBody>
       </p:sp>
       <p:sp>
         <p:nvSpPr>
@@ -3128,11 +2977,11 @@
           <a:bodyPr wrap="square" lIns="0" tIns="0" rIns="0" bIns="0" rtlCol="0" anchor="ctr"/>
           <a:lstStyle/>
           <a:p>
-            <a:pPr indent="0" marL="0">
-              <a:buNone/>
-            </a:pPr>
-            <a:r>
-              <a:rPr lang="en-US" sz="1150" b="1" spc="30" kern="0" dirty="0">
+            <a:pPr marL="0" indent="0">
+              <a:buNone/>
+            </a:pPr>
+            <a:r>
+              <a:rPr lang="en-US" sz="1150" b="1" kern="0" spc="30" dirty="0">
                 <a:solidFill>
                   <a:srgbClr val="8B7CF6"/>
                 </a:solidFill>
@@ -3167,7 +3016,7 @@
           <a:bodyPr wrap="square" lIns="0" tIns="0" rIns="0" bIns="0" rtlCol="0" anchor="t"/>
           <a:lstStyle/>
           <a:p>
-            <a:pPr indent="0" marL="0">
+            <a:pPr marL="0" indent="0">
               <a:lnSpc>
                 <a:spcPct val="130000"/>
               </a:lnSpc>
@@ -3209,11 +3058,11 @@
           <a:bodyPr wrap="square" lIns="0" tIns="0" rIns="0" bIns="0" rtlCol="0" anchor="ctr"/>
           <a:lstStyle/>
           <a:p>
-            <a:pPr indent="0" marL="0">
-              <a:buNone/>
-            </a:pPr>
-            <a:r>
-              <a:rPr lang="en-US" sz="1250" b="1" spc="40" kern="0" dirty="0">
+            <a:pPr marL="0" indent="0">
+              <a:buNone/>
+            </a:pPr>
+            <a:r>
+              <a:rPr lang="en-US" sz="1250" b="1" kern="0" spc="40" dirty="0">
                 <a:solidFill>
                   <a:srgbClr val="4B36C7"/>
                 </a:solidFill>
@@ -3248,7 +3097,7 @@
           <a:bodyPr wrap="square" lIns="0" tIns="0" rIns="0" bIns="0" rtlCol="0" anchor="t"/>
           <a:lstStyle/>
           <a:p>
-            <a:pPr indent="0" marL="0">
+            <a:pPr marL="0" indent="0">
               <a:lnSpc>
                 <a:spcPct val="150000"/>
               </a:lnSpc>
@@ -3268,7 +3117,7 @@
             <a:endParaRPr lang="en-US" sz="1300" dirty="0"/>
           </a:p>
           <a:p>
-            <a:pPr indent="0" marL="0">
+            <a:pPr marL="0" indent="0">
               <a:lnSpc>
                 <a:spcPct val="150000"/>
               </a:lnSpc>
@@ -3305,6 +3154,7 @@
         <a:solidFill>
           <a:srgbClr val="FFFFFF"/>
         </a:solidFill>
+        <a:effectLst/>
       </p:bgPr>
     </p:bg>
     <p:spTree>
@@ -3340,6 +3190,13 @@
           </a:solidFill>
           <a:ln/>
         </p:spPr>
+        <p:txBody>
+          <a:bodyPr/>
+          <a:lstStyle/>
+          <a:p>
+            <a:endParaRPr lang="en-ID"/>
+          </a:p>
+        </p:txBody>
       </p:sp>
       <p:sp>
         <p:nvSpPr>
@@ -3360,6 +3217,13 @@
           </a:solidFill>
           <a:ln/>
         </p:spPr>
+        <p:txBody>
+          <a:bodyPr/>
+          <a:lstStyle/>
+          <a:p>
+            <a:endParaRPr lang="en-ID"/>
+          </a:p>
+        </p:txBody>
       </p:sp>
       <p:sp>
         <p:nvSpPr>
@@ -3382,7 +3246,7 @@
           <a:bodyPr wrap="square" lIns="0" tIns="0" rIns="0" bIns="0" rtlCol="0" anchor="ctr"/>
           <a:lstStyle/>
           <a:p>
-            <a:pPr indent="0" marL="0">
+            <a:pPr marL="0" indent="0">
               <a:buNone/>
             </a:pPr>
             <a:r>
@@ -3396,9 +3260,6 @@
               </a:rPr>
               <a:t>belajar</a:t>
             </a:r>
-            <a:pPr indent="0" marL="0">
-              <a:buNone/>
-            </a:pPr>
             <a:r>
               <a:rPr lang="en-US" sz="2000" b="1" dirty="0">
                 <a:solidFill>
@@ -3435,7 +3296,7 @@
           <a:bodyPr wrap="square" lIns="0" tIns="0" rIns="0" bIns="0" rtlCol="0" anchor="ctr"/>
           <a:lstStyle/>
           <a:p>
-            <a:pPr algn="r" indent="0" marL="0">
+            <a:pPr marL="0" indent="0" algn="r">
               <a:buNone/>
             </a:pPr>
             <a:r>
@@ -3474,7 +3335,7 @@
           <a:bodyPr wrap="square" lIns="0" tIns="0" rIns="0" bIns="0" rtlCol="0" anchor="ctr"/>
           <a:lstStyle/>
           <a:p>
-            <a:pPr indent="0" marL="0">
+            <a:pPr marL="0" indent="0">
               <a:buNone/>
             </a:pPr>
             <a:r>
@@ -3513,11 +3374,11 @@
           <a:bodyPr wrap="square" lIns="0" tIns="0" rIns="0" bIns="0" rtlCol="0" anchor="ctr"/>
           <a:lstStyle/>
           <a:p>
-            <a:pPr indent="0" marL="0">
-              <a:buNone/>
-            </a:pPr>
-            <a:r>
-              <a:rPr lang="en-US" sz="1250" b="1" spc="40" kern="0" dirty="0">
+            <a:pPr marL="0" indent="0">
+              <a:buNone/>
+            </a:pPr>
+            <a:r>
+              <a:rPr lang="en-US" sz="1250" b="1" kern="0" spc="40" dirty="0">
                 <a:solidFill>
                   <a:srgbClr val="4B36C7"/>
                 </a:solidFill>
@@ -3552,7 +3413,7 @@
           <a:bodyPr wrap="square" lIns="0" tIns="0" rIns="0" bIns="0" rtlCol="0" anchor="t"/>
           <a:lstStyle/>
           <a:p>
-            <a:pPr indent="0" marL="0">
+            <a:pPr marL="0" indent="0">
               <a:lnSpc>
                 <a:spcPct val="128000"/>
               </a:lnSpc>
@@ -3599,6 +3460,13 @@
             <a:prstDash val="solid"/>
           </a:ln>
         </p:spPr>
+        <p:txBody>
+          <a:bodyPr/>
+          <a:lstStyle/>
+          <a:p>
+            <a:endParaRPr lang="en-ID"/>
+          </a:p>
+        </p:txBody>
       </p:sp>
       <p:sp>
         <p:nvSpPr>
@@ -3619,6 +3487,13 @@
           </a:solidFill>
           <a:ln/>
         </p:spPr>
+        <p:txBody>
+          <a:bodyPr/>
+          <a:lstStyle/>
+          <a:p>
+            <a:endParaRPr lang="en-ID"/>
+          </a:p>
+        </p:txBody>
       </p:sp>
       <p:sp>
         <p:nvSpPr>
@@ -3641,7 +3516,7 @@
           <a:bodyPr wrap="square" lIns="0" tIns="0" rIns="0" bIns="0" rtlCol="0" anchor="ctr"/>
           <a:lstStyle/>
           <a:p>
-            <a:pPr algn="ctr" indent="0" marL="0">
+            <a:pPr marL="0" indent="0" algn="ctr">
               <a:buNone/>
             </a:pPr>
             <a:r>
@@ -3680,7 +3555,7 @@
           <a:bodyPr wrap="square" lIns="0" tIns="0" rIns="0" bIns="0" rtlCol="0" anchor="ctr"/>
           <a:lstStyle/>
           <a:p>
-            <a:pPr indent="0" marL="0">
+            <a:pPr marL="0" indent="0">
               <a:buNone/>
             </a:pPr>
             <a:r>
@@ -3719,7 +3594,7 @@
           <a:bodyPr wrap="square" lIns="0" tIns="0" rIns="0" bIns="0" rtlCol="0" anchor="t"/>
           <a:lstStyle/>
           <a:p>
-            <a:pPr indent="0" marL="0">
+            <a:pPr marL="0" indent="0">
               <a:lnSpc>
                 <a:spcPct val="122000"/>
               </a:lnSpc>
@@ -3766,6 +3641,13 @@
             <a:prstDash val="solid"/>
           </a:ln>
         </p:spPr>
+        <p:txBody>
+          <a:bodyPr/>
+          <a:lstStyle/>
+          <a:p>
+            <a:endParaRPr lang="en-ID"/>
+          </a:p>
+        </p:txBody>
       </p:sp>
       <p:sp>
         <p:nvSpPr>
@@ -3786,6 +3668,13 @@
           </a:solidFill>
           <a:ln/>
         </p:spPr>
+        <p:txBody>
+          <a:bodyPr/>
+          <a:lstStyle/>
+          <a:p>
+            <a:endParaRPr lang="en-ID"/>
+          </a:p>
+        </p:txBody>
       </p:sp>
       <p:sp>
         <p:nvSpPr>
@@ -3808,7 +3697,7 @@
           <a:bodyPr wrap="square" lIns="0" tIns="0" rIns="0" bIns="0" rtlCol="0" anchor="ctr"/>
           <a:lstStyle/>
           <a:p>
-            <a:pPr algn="ctr" indent="0" marL="0">
+            <a:pPr marL="0" indent="0" algn="ctr">
               <a:buNone/>
             </a:pPr>
             <a:r>
@@ -3847,7 +3736,7 @@
           <a:bodyPr wrap="square" lIns="0" tIns="0" rIns="0" bIns="0" rtlCol="0" anchor="ctr"/>
           <a:lstStyle/>
           <a:p>
-            <a:pPr indent="0" marL="0">
+            <a:pPr marL="0" indent="0">
               <a:buNone/>
             </a:pPr>
             <a:r>
@@ -3886,7 +3775,7 @@
           <a:bodyPr wrap="square" lIns="0" tIns="0" rIns="0" bIns="0" rtlCol="0" anchor="t"/>
           <a:lstStyle/>
           <a:p>
-            <a:pPr indent="0" marL="0">
+            <a:pPr marL="0" indent="0">
               <a:lnSpc>
                 <a:spcPct val="122000"/>
               </a:lnSpc>
@@ -3933,6 +3822,13 @@
             <a:prstDash val="solid"/>
           </a:ln>
         </p:spPr>
+        <p:txBody>
+          <a:bodyPr/>
+          <a:lstStyle/>
+          <a:p>
+            <a:endParaRPr lang="en-ID"/>
+          </a:p>
+        </p:txBody>
       </p:sp>
       <p:sp>
         <p:nvSpPr>
@@ -3953,6 +3849,13 @@
           </a:solidFill>
           <a:ln/>
         </p:spPr>
+        <p:txBody>
+          <a:bodyPr/>
+          <a:lstStyle/>
+          <a:p>
+            <a:endParaRPr lang="en-ID"/>
+          </a:p>
+        </p:txBody>
       </p:sp>
       <p:sp>
         <p:nvSpPr>
@@ -3975,7 +3878,7 @@
           <a:bodyPr wrap="square" lIns="0" tIns="0" rIns="0" bIns="0" rtlCol="0" anchor="ctr"/>
           <a:lstStyle/>
           <a:p>
-            <a:pPr algn="ctr" indent="0" marL="0">
+            <a:pPr marL="0" indent="0" algn="ctr">
               <a:buNone/>
             </a:pPr>
             <a:r>
@@ -4014,7 +3917,7 @@
           <a:bodyPr wrap="square" lIns="0" tIns="0" rIns="0" bIns="0" rtlCol="0" anchor="ctr"/>
           <a:lstStyle/>
           <a:p>
-            <a:pPr indent="0" marL="0">
+            <a:pPr marL="0" indent="0">
               <a:buNone/>
             </a:pPr>
             <a:r>
@@ -4053,7 +3956,7 @@
           <a:bodyPr wrap="square" lIns="0" tIns="0" rIns="0" bIns="0" rtlCol="0" anchor="t"/>
           <a:lstStyle/>
           <a:p>
-            <a:pPr indent="0" marL="0">
+            <a:pPr marL="0" indent="0">
               <a:lnSpc>
                 <a:spcPct val="122000"/>
               </a:lnSpc>
@@ -4100,6 +4003,13 @@
             <a:prstDash val="solid"/>
           </a:ln>
         </p:spPr>
+        <p:txBody>
+          <a:bodyPr/>
+          <a:lstStyle/>
+          <a:p>
+            <a:endParaRPr lang="en-ID"/>
+          </a:p>
+        </p:txBody>
       </p:sp>
       <p:sp>
         <p:nvSpPr>
@@ -4120,6 +4030,13 @@
           </a:solidFill>
           <a:ln/>
         </p:spPr>
+        <p:txBody>
+          <a:bodyPr/>
+          <a:lstStyle/>
+          <a:p>
+            <a:endParaRPr lang="en-ID"/>
+          </a:p>
+        </p:txBody>
       </p:sp>
       <p:sp>
         <p:nvSpPr>
@@ -4142,7 +4059,7 @@
           <a:bodyPr wrap="square" lIns="0" tIns="0" rIns="0" bIns="0" rtlCol="0" anchor="ctr"/>
           <a:lstStyle/>
           <a:p>
-            <a:pPr algn="ctr" indent="0" marL="0">
+            <a:pPr marL="0" indent="0" algn="ctr">
               <a:buNone/>
             </a:pPr>
             <a:r>
@@ -4181,7 +4098,7 @@
           <a:bodyPr wrap="square" lIns="0" tIns="0" rIns="0" bIns="0" rtlCol="0" anchor="ctr"/>
           <a:lstStyle/>
           <a:p>
-            <a:pPr indent="0" marL="0">
+            <a:pPr marL="0" indent="0">
               <a:buNone/>
             </a:pPr>
             <a:r>
@@ -4220,7 +4137,7 @@
           <a:bodyPr wrap="square" lIns="0" tIns="0" rIns="0" bIns="0" rtlCol="0" anchor="t"/>
           <a:lstStyle/>
           <a:p>
-            <a:pPr indent="0" marL="0">
+            <a:pPr marL="0" indent="0">
               <a:lnSpc>
                 <a:spcPct val="122000"/>
               </a:lnSpc>
@@ -4262,7 +4179,7 @@
           <a:bodyPr wrap="square" lIns="0" tIns="0" rIns="0" bIns="0" rtlCol="0" anchor="t"/>
           <a:lstStyle/>
           <a:p>
-            <a:pPr indent="0" marL="0">
+            <a:pPr marL="0" indent="0">
               <a:lnSpc>
                 <a:spcPct val="128000"/>
               </a:lnSpc>
@@ -4299,6 +4216,7 @@
         <a:solidFill>
           <a:srgbClr val="FFFFFF"/>
         </a:solidFill>
+        <a:effectLst/>
       </p:bgPr>
     </p:bg>
     <p:spTree>
@@ -4334,6 +4252,13 @@
           </a:solidFill>
           <a:ln/>
         </p:spPr>
+        <p:txBody>
+          <a:bodyPr/>
+          <a:lstStyle/>
+          <a:p>
+            <a:endParaRPr lang="en-ID"/>
+          </a:p>
+        </p:txBody>
       </p:sp>
       <p:sp>
         <p:nvSpPr>
@@ -4354,6 +4279,13 @@
           </a:solidFill>
           <a:ln/>
         </p:spPr>
+        <p:txBody>
+          <a:bodyPr/>
+          <a:lstStyle/>
+          <a:p>
+            <a:endParaRPr lang="en-ID"/>
+          </a:p>
+        </p:txBody>
       </p:sp>
       <p:sp>
         <p:nvSpPr>
@@ -4376,7 +4308,7 @@
           <a:bodyPr wrap="square" lIns="0" tIns="0" rIns="0" bIns="0" rtlCol="0" anchor="ctr"/>
           <a:lstStyle/>
           <a:p>
-            <a:pPr indent="0" marL="0">
+            <a:pPr marL="0" indent="0">
               <a:buNone/>
             </a:pPr>
             <a:r>
@@ -4390,9 +4322,6 @@
               </a:rPr>
               <a:t>belajar</a:t>
             </a:r>
-            <a:pPr indent="0" marL="0">
-              <a:buNone/>
-            </a:pPr>
             <a:r>
               <a:rPr lang="en-US" sz="2000" b="1" dirty="0">
                 <a:solidFill>
@@ -4429,7 +4358,7 @@
           <a:bodyPr wrap="square" lIns="0" tIns="0" rIns="0" bIns="0" rtlCol="0" anchor="ctr"/>
           <a:lstStyle/>
           <a:p>
-            <a:pPr algn="r" indent="0" marL="0">
+            <a:pPr marL="0" indent="0" algn="r">
               <a:buNone/>
             </a:pPr>
             <a:r>
@@ -4468,7 +4397,7 @@
           <a:bodyPr wrap="square" lIns="0" tIns="0" rIns="0" bIns="0" rtlCol="0" anchor="ctr"/>
           <a:lstStyle/>
           <a:p>
-            <a:pPr indent="0" marL="0">
+            <a:pPr marL="0" indent="0">
               <a:buNone/>
             </a:pPr>
             <a:r>
@@ -4507,11 +4436,11 @@
           <a:bodyPr wrap="square" lIns="0" tIns="0" rIns="0" bIns="0" rtlCol="0" anchor="ctr"/>
           <a:lstStyle/>
           <a:p>
-            <a:pPr indent="0" marL="0">
-              <a:buNone/>
-            </a:pPr>
-            <a:r>
-              <a:rPr lang="en-US" sz="1250" b="1" spc="40" kern="0" dirty="0">
+            <a:pPr marL="0" indent="0">
+              <a:buNone/>
+            </a:pPr>
+            <a:r>
+              <a:rPr lang="en-US" sz="1250" b="1" kern="0" spc="40" dirty="0">
                 <a:solidFill>
                   <a:srgbClr val="4B36C7"/>
                 </a:solidFill>
@@ -4551,6 +4480,13 @@
             <a:prstDash val="solid"/>
           </a:ln>
         </p:spPr>
+        <p:txBody>
+          <a:bodyPr/>
+          <a:lstStyle/>
+          <a:p>
+            <a:endParaRPr lang="en-ID"/>
+          </a:p>
+        </p:txBody>
       </p:sp>
       <p:sp>
         <p:nvSpPr>
@@ -4573,14 +4509,11 @@
           <a:bodyPr wrap="square" lIns="0" tIns="0" rIns="0" bIns="0" rtlCol="0" anchor="ctr"/>
           <a:lstStyle/>
           <a:p>
-            <a:pPr indent="0" marL="0">
-              <a:buNone/>
-            </a:pPr>
-            <a:r>
-              <a:rPr lang="en-US" sz="1200" b="1" spc="30" kern="0" dirty="0">
-                <a:solidFill>
-                  <a:srgbClr val="6B7280"/>
-                </a:solidFill>
+            <a:pPr marL="0" indent="0">
+              <a:buNone/>
+            </a:pPr>
+            <a:r>
+              <a:rPr lang="en-US" sz="1200" b="1" kern="0" spc="30" dirty="0">
                 <a:latin typeface="Helvetica" pitchFamily="34" charset="0"/>
                 <a:ea typeface="Helvetica" pitchFamily="34" charset="-122"/>
                 <a:cs typeface="Helvetica" pitchFamily="34" charset="-120"/>
@@ -4612,7 +4545,7 @@
           <a:bodyPr wrap="square" lIns="0" tIns="0" rIns="0" bIns="0" rtlCol="0" anchor="t"/>
           <a:lstStyle/>
           <a:p>
-            <a:pPr indent="0" marL="0">
+            <a:pPr marL="0" indent="0">
               <a:lnSpc>
                 <a:spcPct val="135000"/>
               </a:lnSpc>
@@ -4632,7 +4565,7 @@
             <a:endParaRPr lang="en-US" sz="1200" dirty="0"/>
           </a:p>
           <a:p>
-            <a:pPr indent="0" marL="0">
+            <a:pPr marL="0" indent="0">
               <a:lnSpc>
                 <a:spcPct val="135000"/>
               </a:lnSpc>
@@ -4652,7 +4585,7 @@
             <a:endParaRPr lang="en-US" sz="1200" dirty="0"/>
           </a:p>
           <a:p>
-            <a:pPr indent="0" marL="0">
+            <a:pPr marL="0" indent="0">
               <a:lnSpc>
                 <a:spcPct val="135000"/>
               </a:lnSpc>
@@ -4699,6 +4632,13 @@
             <a:prstDash val="solid"/>
           </a:ln>
         </p:spPr>
+        <p:txBody>
+          <a:bodyPr/>
+          <a:lstStyle/>
+          <a:p>
+            <a:endParaRPr lang="en-ID"/>
+          </a:p>
+        </p:txBody>
       </p:sp>
       <p:sp>
         <p:nvSpPr>
@@ -4721,11 +4661,11 @@
           <a:bodyPr wrap="square" lIns="0" tIns="0" rIns="0" bIns="0" rtlCol="0" anchor="ctr"/>
           <a:lstStyle/>
           <a:p>
-            <a:pPr indent="0" marL="0">
-              <a:buNone/>
-            </a:pPr>
-            <a:r>
-              <a:rPr lang="en-US" sz="1200" b="1" spc="30" kern="0" dirty="0">
+            <a:pPr marL="0" indent="0">
+              <a:buNone/>
+            </a:pPr>
+            <a:r>
+              <a:rPr lang="en-US" sz="1200" b="1" kern="0" spc="30" dirty="0">
                 <a:solidFill>
                   <a:srgbClr val="4B36C7"/>
                 </a:solidFill>
@@ -4760,7 +4700,7 @@
           <a:bodyPr wrap="square" lIns="0" tIns="0" rIns="0" bIns="0" rtlCol="0" anchor="t"/>
           <a:lstStyle/>
           <a:p>
-            <a:pPr indent="0" marL="0">
+            <a:pPr marL="0" indent="0">
               <a:lnSpc>
                 <a:spcPct val="135000"/>
               </a:lnSpc>
@@ -4780,7 +4720,7 @@
             <a:endParaRPr lang="en-US" sz="1200" dirty="0"/>
           </a:p>
           <a:p>
-            <a:pPr indent="0" marL="0">
+            <a:pPr marL="0" indent="0">
               <a:lnSpc>
                 <a:spcPct val="135000"/>
               </a:lnSpc>
@@ -4800,7 +4740,7 @@
             <a:endParaRPr lang="en-US" sz="1200" dirty="0"/>
           </a:p>
           <a:p>
-            <a:pPr indent="0" marL="0">
+            <a:pPr marL="0" indent="0">
               <a:lnSpc>
                 <a:spcPct val="135000"/>
               </a:lnSpc>
@@ -4837,6 +4777,7 @@
         <a:solidFill>
           <a:srgbClr val="FFFFFF"/>
         </a:solidFill>
+        <a:effectLst/>
       </p:bgPr>
     </p:bg>
     <p:spTree>
@@ -4872,6 +4813,13 @@
           </a:solidFill>
           <a:ln/>
         </p:spPr>
+        <p:txBody>
+          <a:bodyPr/>
+          <a:lstStyle/>
+          <a:p>
+            <a:endParaRPr lang="en-ID"/>
+          </a:p>
+        </p:txBody>
       </p:sp>
       <p:sp>
         <p:nvSpPr>
@@ -4892,6 +4840,13 @@
           </a:solidFill>
           <a:ln/>
         </p:spPr>
+        <p:txBody>
+          <a:bodyPr/>
+          <a:lstStyle/>
+          <a:p>
+            <a:endParaRPr lang="en-ID"/>
+          </a:p>
+        </p:txBody>
       </p:sp>
       <p:sp>
         <p:nvSpPr>
@@ -4914,7 +4869,7 @@
           <a:bodyPr wrap="square" lIns="0" tIns="0" rIns="0" bIns="0" rtlCol="0" anchor="ctr"/>
           <a:lstStyle/>
           <a:p>
-            <a:pPr indent="0" marL="0">
+            <a:pPr marL="0" indent="0">
               <a:buNone/>
             </a:pPr>
             <a:r>
@@ -4928,9 +4883,6 @@
               </a:rPr>
               <a:t>belajar</a:t>
             </a:r>
-            <a:pPr indent="0" marL="0">
-              <a:buNone/>
-            </a:pPr>
             <a:r>
               <a:rPr lang="en-US" sz="2000" b="1" dirty="0">
                 <a:solidFill>
@@ -4967,7 +4919,7 @@
           <a:bodyPr wrap="square" lIns="0" tIns="0" rIns="0" bIns="0" rtlCol="0" anchor="ctr"/>
           <a:lstStyle/>
           <a:p>
-            <a:pPr algn="r" indent="0" marL="0">
+            <a:pPr marL="0" indent="0" algn="r">
               <a:buNone/>
             </a:pPr>
             <a:r>
@@ -5006,7 +4958,7 @@
           <a:bodyPr wrap="square" lIns="0" tIns="0" rIns="0" bIns="0" rtlCol="0" anchor="ctr"/>
           <a:lstStyle/>
           <a:p>
-            <a:pPr indent="0" marL="0">
+            <a:pPr marL="0" indent="0">
               <a:buNone/>
             </a:pPr>
             <a:r>
@@ -5045,11 +4997,11 @@
           <a:bodyPr wrap="square" lIns="0" tIns="0" rIns="0" bIns="0" rtlCol="0" anchor="ctr"/>
           <a:lstStyle/>
           <a:p>
-            <a:pPr indent="0" marL="0">
-              <a:buNone/>
-            </a:pPr>
-            <a:r>
-              <a:rPr lang="en-US" sz="1250" b="1" spc="40" kern="0" dirty="0">
+            <a:pPr marL="0" indent="0">
+              <a:buNone/>
+            </a:pPr>
+            <a:r>
+              <a:rPr lang="en-US" sz="1250" b="1" kern="0" spc="40" dirty="0">
                 <a:solidFill>
                   <a:srgbClr val="4B36C7"/>
                 </a:solidFill>
@@ -5084,7 +5036,7 @@
           <a:bodyPr wrap="square" lIns="0" tIns="0" rIns="0" bIns="0" rtlCol="0" anchor="t"/>
           <a:lstStyle/>
           <a:p>
-            <a:pPr indent="0" marL="0">
+            <a:pPr marL="0" indent="0">
               <a:lnSpc>
                 <a:spcPct val="128000"/>
               </a:lnSpc>
@@ -5131,6 +5083,13 @@
             <a:prstDash val="solid"/>
           </a:ln>
         </p:spPr>
+        <p:txBody>
+          <a:bodyPr/>
+          <a:lstStyle/>
+          <a:p>
+            <a:endParaRPr lang="en-ID"/>
+          </a:p>
+        </p:txBody>
       </p:sp>
       <p:sp>
         <p:nvSpPr>
@@ -5153,11 +5112,11 @@
           <a:bodyPr wrap="square" lIns="0" tIns="0" rIns="0" bIns="0" rtlCol="0" anchor="ctr"/>
           <a:lstStyle/>
           <a:p>
-            <a:pPr indent="0" marL="0">
-              <a:buNone/>
-            </a:pPr>
-            <a:r>
-              <a:rPr lang="en-US" sz="1150" b="1" spc="30" kern="0" dirty="0">
+            <a:pPr marL="0" indent="0">
+              <a:buNone/>
+            </a:pPr>
+            <a:r>
+              <a:rPr lang="en-US" sz="1150" b="1" kern="0" spc="30" dirty="0">
                 <a:solidFill>
                   <a:srgbClr val="8B7CF6"/>
                 </a:solidFill>
@@ -5192,7 +5151,7 @@
           <a:bodyPr wrap="square" lIns="0" tIns="0" rIns="0" bIns="0" rtlCol="0" anchor="t"/>
           <a:lstStyle/>
           <a:p>
-            <a:pPr indent="0" marL="0">
+            <a:pPr marL="0" indent="0">
               <a:lnSpc>
                 <a:spcPct val="130000"/>
               </a:lnSpc>
@@ -5234,7 +5193,7 @@
           <a:bodyPr wrap="square" lIns="0" tIns="0" rIns="0" bIns="0" rtlCol="0" anchor="t"/>
           <a:lstStyle/>
           <a:p>
-            <a:pPr indent="0" marL="0">
+            <a:pPr marL="0" indent="0">
               <a:lnSpc>
                 <a:spcPct val="128000"/>
               </a:lnSpc>
@@ -5271,6 +5230,7 @@
         <a:solidFill>
           <a:srgbClr val="FFFFFF"/>
         </a:solidFill>
+        <a:effectLst/>
       </p:bgPr>
     </p:bg>
     <p:spTree>
@@ -5306,6 +5266,13 @@
           </a:solidFill>
           <a:ln/>
         </p:spPr>
+        <p:txBody>
+          <a:bodyPr/>
+          <a:lstStyle/>
+          <a:p>
+            <a:endParaRPr lang="en-ID"/>
+          </a:p>
+        </p:txBody>
       </p:sp>
       <p:sp>
         <p:nvSpPr>
@@ -5326,6 +5293,13 @@
           </a:solidFill>
           <a:ln/>
         </p:spPr>
+        <p:txBody>
+          <a:bodyPr/>
+          <a:lstStyle/>
+          <a:p>
+            <a:endParaRPr lang="en-ID"/>
+          </a:p>
+        </p:txBody>
       </p:sp>
       <p:sp>
         <p:nvSpPr>
@@ -5348,7 +5322,7 @@
           <a:bodyPr wrap="square" lIns="0" tIns="0" rIns="0" bIns="0" rtlCol="0" anchor="ctr"/>
           <a:lstStyle/>
           <a:p>
-            <a:pPr indent="0" marL="0">
+            <a:pPr marL="0" indent="0">
               <a:buNone/>
             </a:pPr>
             <a:r>
@@ -5362,9 +5336,6 @@
               </a:rPr>
               <a:t>belajar</a:t>
             </a:r>
-            <a:pPr indent="0" marL="0">
-              <a:buNone/>
-            </a:pPr>
             <a:r>
               <a:rPr lang="en-US" sz="2000" b="1" dirty="0">
                 <a:solidFill>
@@ -5401,7 +5372,7 @@
           <a:bodyPr wrap="square" lIns="0" tIns="0" rIns="0" bIns="0" rtlCol="0" anchor="ctr"/>
           <a:lstStyle/>
           <a:p>
-            <a:pPr algn="r" indent="0" marL="0">
+            <a:pPr marL="0" indent="0" algn="r">
               <a:buNone/>
             </a:pPr>
             <a:r>
@@ -5440,7 +5411,7 @@
           <a:bodyPr wrap="square" lIns="0" tIns="0" rIns="0" bIns="0" rtlCol="0" anchor="ctr"/>
           <a:lstStyle/>
           <a:p>
-            <a:pPr indent="0" marL="0">
+            <a:pPr marL="0" indent="0">
               <a:buNone/>
             </a:pPr>
             <a:r>
@@ -5479,11 +5450,11 @@
           <a:bodyPr wrap="square" lIns="0" tIns="0" rIns="0" bIns="0" rtlCol="0" anchor="ctr"/>
           <a:lstStyle/>
           <a:p>
-            <a:pPr indent="0" marL="0">
-              <a:buNone/>
-            </a:pPr>
-            <a:r>
-              <a:rPr lang="en-US" sz="1250" b="1" spc="40" kern="0" dirty="0">
+            <a:pPr marL="0" indent="0">
+              <a:buNone/>
+            </a:pPr>
+            <a:r>
+              <a:rPr lang="en-US" sz="1250" b="1" kern="0" spc="40" dirty="0">
                 <a:solidFill>
                   <a:srgbClr val="4B36C7"/>
                 </a:solidFill>
@@ -5518,7 +5489,7 @@
           <a:bodyPr wrap="square" lIns="0" tIns="0" rIns="0" bIns="0" rtlCol="0" anchor="t"/>
           <a:lstStyle/>
           <a:p>
-            <a:pPr indent="0" marL="0">
+            <a:pPr marL="0" indent="0">
               <a:lnSpc>
                 <a:spcPct val="128000"/>
               </a:lnSpc>
@@ -5565,6 +5536,13 @@
             <a:prstDash val="solid"/>
           </a:ln>
         </p:spPr>
+        <p:txBody>
+          <a:bodyPr/>
+          <a:lstStyle/>
+          <a:p>
+            <a:endParaRPr lang="en-ID"/>
+          </a:p>
+        </p:txBody>
       </p:sp>
       <p:sp>
         <p:nvSpPr>
@@ -5587,11 +5565,11 @@
           <a:bodyPr wrap="square" lIns="0" tIns="0" rIns="0" bIns="0" rtlCol="0" anchor="ctr"/>
           <a:lstStyle/>
           <a:p>
-            <a:pPr indent="0" marL="0">
-              <a:buNone/>
-            </a:pPr>
-            <a:r>
-              <a:rPr lang="en-US" sz="1150" b="1" spc="30" kern="0" dirty="0">
+            <a:pPr marL="0" indent="0">
+              <a:buNone/>
+            </a:pPr>
+            <a:r>
+              <a:rPr lang="en-US" sz="1150" b="1" kern="0" spc="30" dirty="0">
                 <a:solidFill>
                   <a:srgbClr val="8B7CF6"/>
                 </a:solidFill>
@@ -5626,7 +5604,7 @@
           <a:bodyPr wrap="square" lIns="0" tIns="0" rIns="0" bIns="0" rtlCol="0" anchor="t"/>
           <a:lstStyle/>
           <a:p>
-            <a:pPr indent="0" marL="0">
+            <a:pPr marL="0" indent="0">
               <a:lnSpc>
                 <a:spcPct val="130000"/>
               </a:lnSpc>
@@ -5668,7 +5646,7 @@
           <a:bodyPr wrap="square" lIns="0" tIns="0" rIns="0" bIns="0" rtlCol="0" anchor="t"/>
           <a:lstStyle/>
           <a:p>
-            <a:pPr indent="0" marL="0">
+            <a:pPr marL="0" indent="0">
               <a:lnSpc>
                 <a:spcPct val="128000"/>
               </a:lnSpc>
@@ -5705,6 +5683,7 @@
         <a:solidFill>
           <a:srgbClr val="FFFFFF"/>
         </a:solidFill>
+        <a:effectLst/>
       </p:bgPr>
     </p:bg>
     <p:spTree>
@@ -5740,6 +5719,13 @@
           </a:solidFill>
           <a:ln/>
         </p:spPr>
+        <p:txBody>
+          <a:bodyPr/>
+          <a:lstStyle/>
+          <a:p>
+            <a:endParaRPr lang="en-ID"/>
+          </a:p>
+        </p:txBody>
       </p:sp>
       <p:sp>
         <p:nvSpPr>
@@ -5760,6 +5746,13 @@
           </a:solidFill>
           <a:ln/>
         </p:spPr>
+        <p:txBody>
+          <a:bodyPr/>
+          <a:lstStyle/>
+          <a:p>
+            <a:endParaRPr lang="en-ID"/>
+          </a:p>
+        </p:txBody>
       </p:sp>
       <p:sp>
         <p:nvSpPr>
@@ -5782,7 +5775,7 @@
           <a:bodyPr wrap="square" lIns="0" tIns="0" rIns="0" bIns="0" rtlCol="0" anchor="ctr"/>
           <a:lstStyle/>
           <a:p>
-            <a:pPr indent="0" marL="0">
+            <a:pPr marL="0" indent="0">
               <a:buNone/>
             </a:pPr>
             <a:r>
@@ -5796,9 +5789,6 @@
               </a:rPr>
               <a:t>belajar</a:t>
             </a:r>
-            <a:pPr indent="0" marL="0">
-              <a:buNone/>
-            </a:pPr>
             <a:r>
               <a:rPr lang="en-US" sz="2000" b="1" dirty="0">
                 <a:solidFill>
@@ -5835,7 +5825,7 @@
           <a:bodyPr wrap="square" lIns="0" tIns="0" rIns="0" bIns="0" rtlCol="0" anchor="ctr"/>
           <a:lstStyle/>
           <a:p>
-            <a:pPr algn="r" indent="0" marL="0">
+            <a:pPr marL="0" indent="0" algn="r">
               <a:buNone/>
             </a:pPr>
             <a:r>
@@ -5874,7 +5864,7 @@
           <a:bodyPr wrap="square" lIns="0" tIns="0" rIns="0" bIns="0" rtlCol="0" anchor="ctr"/>
           <a:lstStyle/>
           <a:p>
-            <a:pPr indent="0" marL="0">
+            <a:pPr marL="0" indent="0">
               <a:buNone/>
             </a:pPr>
             <a:r>
@@ -5913,11 +5903,11 @@
           <a:bodyPr wrap="square" lIns="0" tIns="0" rIns="0" bIns="0" rtlCol="0" anchor="ctr"/>
           <a:lstStyle/>
           <a:p>
-            <a:pPr indent="0" marL="0">
-              <a:buNone/>
-            </a:pPr>
-            <a:r>
-              <a:rPr lang="en-US" sz="1250" b="1" spc="40" kern="0" dirty="0">
+            <a:pPr marL="0" indent="0">
+              <a:buNone/>
+            </a:pPr>
+            <a:r>
+              <a:rPr lang="en-US" sz="1250" b="1" kern="0" spc="40" dirty="0">
                 <a:solidFill>
                   <a:srgbClr val="4B36C7"/>
                 </a:solidFill>
@@ -5957,6 +5947,13 @@
             <a:prstDash val="solid"/>
           </a:ln>
         </p:spPr>
+        <p:txBody>
+          <a:bodyPr/>
+          <a:lstStyle/>
+          <a:p>
+            <a:endParaRPr lang="en-ID"/>
+          </a:p>
+        </p:txBody>
       </p:sp>
       <p:sp>
         <p:nvSpPr>
@@ -5979,11 +5976,11 @@
           <a:bodyPr wrap="square" lIns="0" tIns="0" rIns="0" bIns="0" rtlCol="0" anchor="ctr"/>
           <a:lstStyle/>
           <a:p>
-            <a:pPr indent="0" marL="0">
-              <a:buNone/>
-            </a:pPr>
-            <a:r>
-              <a:rPr lang="en-US" sz="1250" b="1" spc="30" kern="0" dirty="0">
+            <a:pPr marL="0" indent="0">
+              <a:buNone/>
+            </a:pPr>
+            <a:r>
+              <a:rPr lang="en-US" sz="1250" b="1" kern="0" spc="30" dirty="0">
                 <a:solidFill>
                   <a:srgbClr val="1A7A44"/>
                 </a:solidFill>
@@ -6018,7 +6015,7 @@
           <a:bodyPr wrap="square" lIns="0" tIns="0" rIns="0" bIns="0" rtlCol="0" anchor="t"/>
           <a:lstStyle/>
           <a:p>
-            <a:pPr indent="0" marL="0">
+            <a:pPr marL="0" indent="0">
               <a:lnSpc>
                 <a:spcPct val="130000"/>
               </a:lnSpc>
@@ -6065,6 +6062,13 @@
             <a:prstDash val="solid"/>
           </a:ln>
         </p:spPr>
+        <p:txBody>
+          <a:bodyPr/>
+          <a:lstStyle/>
+          <a:p>
+            <a:endParaRPr lang="en-ID"/>
+          </a:p>
+        </p:txBody>
       </p:sp>
       <p:sp>
         <p:nvSpPr>
@@ -6087,11 +6091,11 @@
           <a:bodyPr wrap="square" lIns="0" tIns="0" rIns="0" bIns="0" rtlCol="0" anchor="ctr"/>
           <a:lstStyle/>
           <a:p>
-            <a:pPr indent="0" marL="0">
-              <a:buNone/>
-            </a:pPr>
-            <a:r>
-              <a:rPr lang="en-US" sz="1250" b="1" spc="30" kern="0" dirty="0">
+            <a:pPr marL="0" indent="0">
+              <a:buNone/>
+            </a:pPr>
+            <a:r>
+              <a:rPr lang="en-US" sz="1250" b="1" kern="0" spc="30" dirty="0">
                 <a:solidFill>
                   <a:srgbClr val="1A7A44"/>
                 </a:solidFill>
@@ -6126,7 +6130,7 @@
           <a:bodyPr wrap="square" lIns="0" tIns="0" rIns="0" bIns="0" rtlCol="0" anchor="t"/>
           <a:lstStyle/>
           <a:p>
-            <a:pPr indent="0" marL="0">
+            <a:pPr marL="0" indent="0">
               <a:lnSpc>
                 <a:spcPct val="130000"/>
               </a:lnSpc>
@@ -6163,6 +6167,7 @@
         <a:solidFill>
           <a:srgbClr val="FFFFFF"/>
         </a:solidFill>
+        <a:effectLst/>
       </p:bgPr>
     </p:bg>
     <p:spTree>
@@ -6198,6 +6203,13 @@
           </a:solidFill>
           <a:ln/>
         </p:spPr>
+        <p:txBody>
+          <a:bodyPr/>
+          <a:lstStyle/>
+          <a:p>
+            <a:endParaRPr lang="en-ID"/>
+          </a:p>
+        </p:txBody>
       </p:sp>
       <p:sp>
         <p:nvSpPr>
@@ -6218,6 +6230,13 @@
           </a:solidFill>
           <a:ln/>
         </p:spPr>
+        <p:txBody>
+          <a:bodyPr/>
+          <a:lstStyle/>
+          <a:p>
+            <a:endParaRPr lang="en-ID"/>
+          </a:p>
+        </p:txBody>
       </p:sp>
       <p:sp>
         <p:nvSpPr>
@@ -6240,7 +6259,7 @@
           <a:bodyPr wrap="square" lIns="0" tIns="0" rIns="0" bIns="0" rtlCol="0" anchor="ctr"/>
           <a:lstStyle/>
           <a:p>
-            <a:pPr indent="0" marL="0">
+            <a:pPr marL="0" indent="0">
               <a:buNone/>
             </a:pPr>
             <a:r>
@@ -6254,9 +6273,6 @@
               </a:rPr>
               <a:t>belajar</a:t>
             </a:r>
-            <a:pPr indent="0" marL="0">
-              <a:buNone/>
-            </a:pPr>
             <a:r>
               <a:rPr lang="en-US" sz="2000" b="1" dirty="0">
                 <a:solidFill>
@@ -6293,7 +6309,7 @@
           <a:bodyPr wrap="square" lIns="0" tIns="0" rIns="0" bIns="0" rtlCol="0" anchor="ctr"/>
           <a:lstStyle/>
           <a:p>
-            <a:pPr algn="r" indent="0" marL="0">
+            <a:pPr marL="0" indent="0" algn="r">
               <a:buNone/>
             </a:pPr>
             <a:r>
@@ -6332,7 +6348,7 @@
           <a:bodyPr wrap="square" lIns="0" tIns="0" rIns="0" bIns="0" rtlCol="0" anchor="ctr"/>
           <a:lstStyle/>
           <a:p>
-            <a:pPr indent="0" marL="0">
+            <a:pPr marL="0" indent="0">
               <a:buNone/>
             </a:pPr>
             <a:r>
@@ -6371,11 +6387,11 @@
           <a:bodyPr wrap="square" lIns="0" tIns="0" rIns="0" bIns="0" rtlCol="0" anchor="ctr"/>
           <a:lstStyle/>
           <a:p>
-            <a:pPr indent="0" marL="0">
-              <a:buNone/>
-            </a:pPr>
-            <a:r>
-              <a:rPr lang="en-US" sz="1250" b="1" spc="40" kern="0" dirty="0">
+            <a:pPr marL="0" indent="0">
+              <a:buNone/>
+            </a:pPr>
+            <a:r>
+              <a:rPr lang="en-US" sz="1250" b="1" kern="0" spc="40" dirty="0">
                 <a:solidFill>
                   <a:srgbClr val="4B36C7"/>
                 </a:solidFill>
@@ -6415,6 +6431,13 @@
             <a:prstDash val="solid"/>
           </a:ln>
         </p:spPr>
+        <p:txBody>
+          <a:bodyPr/>
+          <a:lstStyle/>
+          <a:p>
+            <a:endParaRPr lang="en-ID"/>
+          </a:p>
+        </p:txBody>
       </p:sp>
       <p:sp>
         <p:nvSpPr>
@@ -6437,11 +6460,11 @@
           <a:bodyPr wrap="square" lIns="0" tIns="0" rIns="0" bIns="0" rtlCol="0" anchor="ctr"/>
           <a:lstStyle/>
           <a:p>
-            <a:pPr indent="0" marL="0">
-              <a:buNone/>
-            </a:pPr>
-            <a:r>
-              <a:rPr lang="en-US" sz="1250" b="1" spc="30" kern="0" dirty="0">
+            <a:pPr marL="0" indent="0">
+              <a:buNone/>
+            </a:pPr>
+            <a:r>
+              <a:rPr lang="en-US" sz="1250" b="1" kern="0" spc="30" dirty="0">
                 <a:solidFill>
                   <a:srgbClr val="4B36C7"/>
                 </a:solidFill>
@@ -6476,7 +6499,7 @@
           <a:bodyPr wrap="square" lIns="0" tIns="0" rIns="0" bIns="0" rtlCol="0" anchor="t"/>
           <a:lstStyle/>
           <a:p>
-            <a:pPr indent="0" marL="0">
+            <a:pPr marL="0" indent="0">
               <a:lnSpc>
                 <a:spcPct val="130000"/>
               </a:lnSpc>
@@ -6523,6 +6546,13 @@
             <a:prstDash val="solid"/>
           </a:ln>
         </p:spPr>
+        <p:txBody>
+          <a:bodyPr/>
+          <a:lstStyle/>
+          <a:p>
+            <a:endParaRPr lang="en-ID"/>
+          </a:p>
+        </p:txBody>
       </p:sp>
       <p:sp>
         <p:nvSpPr>
@@ -6545,11 +6575,11 @@
           <a:bodyPr wrap="square" lIns="0" tIns="0" rIns="0" bIns="0" rtlCol="0" anchor="ctr"/>
           <a:lstStyle/>
           <a:p>
-            <a:pPr indent="0" marL="0">
-              <a:buNone/>
-            </a:pPr>
-            <a:r>
-              <a:rPr lang="en-US" sz="1150" b="1" spc="30" kern="0" dirty="0">
+            <a:pPr marL="0" indent="0">
+              <a:buNone/>
+            </a:pPr>
+            <a:r>
+              <a:rPr lang="en-US" sz="1150" b="1" kern="0" spc="30" dirty="0">
                 <a:solidFill>
                   <a:srgbClr val="8B7CF6"/>
                 </a:solidFill>
@@ -6584,7 +6614,7 @@
           <a:bodyPr wrap="square" lIns="0" tIns="0" rIns="0" bIns="0" rtlCol="0" anchor="t"/>
           <a:lstStyle/>
           <a:p>
-            <a:pPr indent="0" marL="0">
+            <a:pPr marL="0" indent="0">
               <a:lnSpc>
                 <a:spcPct val="130000"/>
               </a:lnSpc>
@@ -6906,4 +6936,319 @@
     </a:ext>
   </a:extLst>
 </a:theme>
+</file>
+
+<file path=ppt/theme/theme2.xml><?xml version="1.0" encoding="utf-8"?>
+<a:theme xmlns:a="http://schemas.openxmlformats.org/drawingml/2006/main" name="Office Theme">
+  <a:themeElements>
+    <a:clrScheme name="Office">
+      <a:dk1>
+        <a:sysClr val="windowText" lastClr="000000"/>
+      </a:dk1>
+      <a:lt1>
+        <a:sysClr val="window" lastClr="FFFFFF"/>
+      </a:lt1>
+      <a:dk2>
+        <a:srgbClr val="0E2841"/>
+      </a:dk2>
+      <a:lt2>
+        <a:srgbClr val="E8E8E8"/>
+      </a:lt2>
+      <a:accent1>
+        <a:srgbClr val="156082"/>
+      </a:accent1>
+      <a:accent2>
+        <a:srgbClr val="E97132"/>
+      </a:accent2>
+      <a:accent3>
+        <a:srgbClr val="196B24"/>
+      </a:accent3>
+      <a:accent4>
+        <a:srgbClr val="0F9ED5"/>
+      </a:accent4>
+      <a:accent5>
+        <a:srgbClr val="A02B93"/>
+      </a:accent5>
+      <a:accent6>
+        <a:srgbClr val="4EA72E"/>
+      </a:accent6>
+      <a:hlink>
+        <a:srgbClr val="467886"/>
+      </a:hlink>
+      <a:folHlink>
+        <a:srgbClr val="96607D"/>
+      </a:folHlink>
+    </a:clrScheme>
+    <a:fontScheme name="Office">
+      <a:majorFont>
+        <a:latin typeface="Aptos Display" panose="02110004020202020204"/>
+        <a:ea typeface=""/>
+        <a:cs typeface=""/>
+        <a:font script="Jpan" typeface="游ゴシック Light"/>
+        <a:font script="Hang" typeface="맑은 고딕"/>
+        <a:font script="Hans" typeface="等线 Light"/>
+        <a:font script="Hant" typeface="新細明體"/>
+        <a:font script="Arab" typeface="Times New Roman"/>
+        <a:font script="Hebr" typeface="Times New Roman"/>
+        <a:font script="Thai" typeface="Angsana New"/>
+        <a:font script="Ethi" typeface="Nyala"/>
+        <a:font script="Beng" typeface="Vrinda"/>
+        <a:font script="Gujr" typeface="Shruti"/>
+        <a:font script="Khmr" typeface="MoolBoran"/>
+        <a:font script="Knda" typeface="Tunga"/>
+        <a:font script="Guru" typeface="Raavi"/>
+        <a:font script="Cans" typeface="Euphemia"/>
+        <a:font script="Cher" typeface="Plantagenet Cherokee"/>
+        <a:font script="Yiii" typeface="Microsoft Yi Baiti"/>
+        <a:font script="Tibt" typeface="Microsoft Himalaya"/>
+        <a:font script="Thaa" typeface="MV Boli"/>
+        <a:font script="Deva" typeface="Mangal"/>
+        <a:font script="Telu" typeface="Gautami"/>
+        <a:font script="Taml" typeface="Latha"/>
+        <a:font script="Syrc" typeface="Estrangelo Edessa"/>
+        <a:font script="Orya" typeface="Kalinga"/>
+        <a:font script="Mlym" typeface="Kartika"/>
+        <a:font script="Laoo" typeface="DokChampa"/>
+        <a:font script="Sinh" typeface="Iskoola Pota"/>
+        <a:font script="Mong" typeface="Mongolian Baiti"/>
+        <a:font script="Viet" typeface="Times New Roman"/>
+        <a:font script="Uigh" typeface="Microsoft Uighur"/>
+        <a:font script="Geor" typeface="Sylfaen"/>
+        <a:font script="Armn" typeface="Arial"/>
+        <a:font script="Bugi" typeface="Leelawadee UI"/>
+        <a:font script="Bopo" typeface="Microsoft JhengHei"/>
+        <a:font script="Java" typeface="Javanese Text"/>
+        <a:font script="Lisu" typeface="Segoe UI"/>
+        <a:font script="Mymr" typeface="Myanmar Text"/>
+        <a:font script="Nkoo" typeface="Ebrima"/>
+        <a:font script="Olck" typeface="Nirmala UI"/>
+        <a:font script="Osma" typeface="Ebrima"/>
+        <a:font script="Phag" typeface="Phagspa"/>
+        <a:font script="Syrn" typeface="Estrangelo Edessa"/>
+        <a:font script="Syrj" typeface="Estrangelo Edessa"/>
+        <a:font script="Syre" typeface="Estrangelo Edessa"/>
+        <a:font script="Sora" typeface="Nirmala UI"/>
+        <a:font script="Tale" typeface="Microsoft Tai Le"/>
+        <a:font script="Talu" typeface="Microsoft New Tai Lue"/>
+        <a:font script="Tfng" typeface="Ebrima"/>
+      </a:majorFont>
+      <a:minorFont>
+        <a:latin typeface="Aptos" panose="02110004020202020204"/>
+        <a:ea typeface=""/>
+        <a:cs typeface=""/>
+        <a:font script="Jpan" typeface="游ゴシック"/>
+        <a:font script="Hang" typeface="맑은 고딕"/>
+        <a:font script="Hans" typeface="等线"/>
+        <a:font script="Hant" typeface="新細明體"/>
+        <a:font script="Arab" typeface="Arial"/>
+        <a:font script="Hebr" typeface="Arial"/>
+        <a:font script="Thai" typeface="Cordia New"/>
+        <a:font script="Ethi" typeface="Nyala"/>
+        <a:font script="Beng" typeface="Vrinda"/>
+        <a:font script="Gujr" typeface="Shruti"/>
+        <a:font script="Khmr" typeface="DaunPenh"/>
+        <a:font script="Knda" typeface="Tunga"/>
+        <a:font script="Guru" typeface="Raavi"/>
+        <a:font script="Cans" typeface="Euphemia"/>
+        <a:font script="Cher" typeface="Plantagenet Cherokee"/>
+        <a:font script="Yiii" typeface="Microsoft Yi Baiti"/>
+        <a:font script="Tibt" typeface="Microsoft Himalaya"/>
+        <a:font script="Thaa" typeface="MV Boli"/>
+        <a:font script="Deva" typeface="Mangal"/>
+        <a:font script="Telu" typeface="Gautami"/>
+        <a:font script="Taml" typeface="Latha"/>
+        <a:font script="Syrc" typeface="Estrangelo Edessa"/>
+        <a:font script="Orya" typeface="Kalinga"/>
+        <a:font script="Mlym" typeface="Kartika"/>
+        <a:font script="Laoo" typeface="DokChampa"/>
+        <a:font script="Sinh" typeface="Iskoola Pota"/>
+        <a:font script="Mong" typeface="Mongolian Baiti"/>
+        <a:font script="Viet" typeface="Arial"/>
+        <a:font script="Uigh" typeface="Microsoft Uighur"/>
+        <a:font script="Geor" typeface="Sylfaen"/>
+        <a:font script="Armn" typeface="Arial"/>
+        <a:font script="Bugi" typeface="Leelawadee UI"/>
+        <a:font script="Bopo" typeface="Microsoft JhengHei"/>
+        <a:font script="Java" typeface="Javanese Text"/>
+        <a:font script="Lisu" typeface="Segoe UI"/>
+        <a:font script="Mymr" typeface="Myanmar Text"/>
+        <a:font script="Nkoo" typeface="Ebrima"/>
+        <a:font script="Olck" typeface="Nirmala UI"/>
+        <a:font script="Osma" typeface="Ebrima"/>
+        <a:font script="Phag" typeface="Phagspa"/>
+        <a:font script="Syrn" typeface="Estrangelo Edessa"/>
+        <a:font script="Syrj" typeface="Estrangelo Edessa"/>
+        <a:font script="Syre" typeface="Estrangelo Edessa"/>
+        <a:font script="Sora" typeface="Nirmala UI"/>
+        <a:font script="Tale" typeface="Microsoft Tai Le"/>
+        <a:font script="Talu" typeface="Microsoft New Tai Lue"/>
+        <a:font script="Tfng" typeface="Ebrima"/>
+      </a:minorFont>
+    </a:fontScheme>
+    <a:fmtScheme name="Office">
+      <a:fillStyleLst>
+        <a:solidFill>
+          <a:schemeClr val="phClr"/>
+        </a:solidFill>
+        <a:gradFill rotWithShape="1">
+          <a:gsLst>
+            <a:gs pos="0">
+              <a:schemeClr val="phClr">
+                <a:lumMod val="110000"/>
+                <a:satMod val="105000"/>
+                <a:tint val="67000"/>
+              </a:schemeClr>
+            </a:gs>
+            <a:gs pos="50000">
+              <a:schemeClr val="phClr">
+                <a:lumMod val="105000"/>
+                <a:satMod val="103000"/>
+                <a:tint val="73000"/>
+              </a:schemeClr>
+            </a:gs>
+            <a:gs pos="100000">
+              <a:schemeClr val="phClr">
+                <a:lumMod val="105000"/>
+                <a:satMod val="109000"/>
+                <a:tint val="81000"/>
+              </a:schemeClr>
+            </a:gs>
+          </a:gsLst>
+          <a:lin ang="5400000" scaled="0"/>
+        </a:gradFill>
+        <a:gradFill rotWithShape="1">
+          <a:gsLst>
+            <a:gs pos="0">
+              <a:schemeClr val="phClr">
+                <a:satMod val="103000"/>
+                <a:lumMod val="102000"/>
+                <a:tint val="94000"/>
+              </a:schemeClr>
+            </a:gs>
+            <a:gs pos="50000">
+              <a:schemeClr val="phClr">
+                <a:satMod val="110000"/>
+                <a:lumMod val="100000"/>
+                <a:shade val="100000"/>
+              </a:schemeClr>
+            </a:gs>
+            <a:gs pos="100000">
+              <a:schemeClr val="phClr">
+                <a:lumMod val="99000"/>
+                <a:satMod val="120000"/>
+                <a:shade val="78000"/>
+              </a:schemeClr>
+            </a:gs>
+          </a:gsLst>
+          <a:lin ang="5400000" scaled="0"/>
+        </a:gradFill>
+      </a:fillStyleLst>
+      <a:lnStyleLst>
+        <a:ln w="12700" cap="flat" cmpd="sng" algn="ctr">
+          <a:solidFill>
+            <a:schemeClr val="phClr"/>
+          </a:solidFill>
+          <a:prstDash val="solid"/>
+          <a:miter lim="800000"/>
+        </a:ln>
+        <a:ln w="19050" cap="flat" cmpd="sng" algn="ctr">
+          <a:solidFill>
+            <a:schemeClr val="phClr"/>
+          </a:solidFill>
+          <a:prstDash val="solid"/>
+          <a:miter lim="800000"/>
+        </a:ln>
+        <a:ln w="25400" cap="flat" cmpd="sng" algn="ctr">
+          <a:solidFill>
+            <a:schemeClr val="phClr"/>
+          </a:solidFill>
+          <a:prstDash val="solid"/>
+          <a:miter lim="800000"/>
+        </a:ln>
+      </a:lnStyleLst>
+      <a:effectStyleLst>
+        <a:effectStyle>
+          <a:effectLst/>
+        </a:effectStyle>
+        <a:effectStyle>
+          <a:effectLst/>
+        </a:effectStyle>
+        <a:effectStyle>
+          <a:effectLst>
+            <a:outerShdw blurRad="57150" dist="19050" dir="5400000" algn="ctr" rotWithShape="0">
+              <a:srgbClr val="000000">
+                <a:alpha val="63000"/>
+              </a:srgbClr>
+            </a:outerShdw>
+          </a:effectLst>
+        </a:effectStyle>
+      </a:effectStyleLst>
+      <a:bgFillStyleLst>
+        <a:solidFill>
+          <a:schemeClr val="phClr"/>
+        </a:solidFill>
+        <a:solidFill>
+          <a:schemeClr val="phClr">
+            <a:tint val="95000"/>
+            <a:satMod val="170000"/>
+          </a:schemeClr>
+        </a:solidFill>
+        <a:gradFill rotWithShape="1">
+          <a:gsLst>
+            <a:gs pos="0">
+              <a:schemeClr val="phClr">
+                <a:tint val="93000"/>
+                <a:satMod val="150000"/>
+                <a:shade val="98000"/>
+                <a:lumMod val="102000"/>
+              </a:schemeClr>
+            </a:gs>
+            <a:gs pos="50000">
+              <a:schemeClr val="phClr">
+                <a:tint val="98000"/>
+                <a:satMod val="130000"/>
+                <a:shade val="90000"/>
+                <a:lumMod val="103000"/>
+              </a:schemeClr>
+            </a:gs>
+            <a:gs pos="100000">
+              <a:schemeClr val="phClr">
+                <a:shade val="63000"/>
+                <a:satMod val="120000"/>
+              </a:schemeClr>
+            </a:gs>
+          </a:gsLst>
+          <a:lin ang="5400000" scaled="0"/>
+        </a:gradFill>
+      </a:bgFillStyleLst>
+    </a:fmtScheme>
+  </a:themeElements>
+  <a:objectDefaults>
+    <a:lnDef>
+      <a:spPr/>
+      <a:bodyPr/>
+      <a:lstStyle/>
+      <a:style>
+        <a:lnRef idx="2">
+          <a:schemeClr val="accent1"/>
+        </a:lnRef>
+        <a:fillRef idx="0">
+          <a:schemeClr val="accent1"/>
+        </a:fillRef>
+        <a:effectRef idx="1">
+          <a:schemeClr val="accent1"/>
+        </a:effectRef>
+        <a:fontRef idx="minor">
+          <a:schemeClr val="tx1"/>
+        </a:fontRef>
+      </a:style>
+    </a:lnDef>
+  </a:objectDefaults>
+  <a:extraClrSchemeLst/>
+  <a:extLst>
+    <a:ext uri="{05A4C25C-085E-4340-85A3-A5531E510DB2}">
+      <thm15:themeFamily xmlns:thm15="http://schemas.microsoft.com/office/thememl/2012/main" name="Office Theme" id="{2E142A2C-CD16-42D6-873A-C26D2A0506FA}" vid="{1BDDFF52-6CD6-40A5-AB3C-68EB2F1E4D0A}"/>
+    </a:ext>
+  </a:extLst>
+</a:theme>
 </file>
</xml_diff>